<commit_message>
Deck: the full team, slide 2 with the recording's own audio, slide 8 on impact and the roadmap
- Slide 1 and the documentation cover name the whole team: Tanmay Singh, Panshul Arora,
  Naman Rai and Devansh Goenka (the video script had "Pranjal" by mistake)
- Slide 2: each moment of travel_19 shows its waveform, cut from the benchmark recording
  at the recognizer's word times
- Slide 8: where the same guarantee matters across Samsung surfaces (from the use-case
  research), and the roadmap as a PRISM worklet
</commit_message>
<xml_diff>
--- a/SRM_SE7EN.pptx
+++ b/SRM_SE7EN.pptx
@@ -3129,7 +3129,7 @@
                 <a:ea typeface="Segoe UI" pitchFamily="34" charset="-122"/>
                 <a:cs typeface="Segoe UI" pitchFamily="34" charset="-120"/>
               </a:rPr>
-              <a:t>Tanmay Singh  ·  Pranjal  ·  Naman</a:t>
+              <a:t>Tanmay Singh  ·  Panshul Arora  ·  Naman Rai  ·  Devansh Goenka</a:t>
             </a:r>
             <a:endParaRPr lang="en-US" sz="1300" dirty="0"/>
           </a:p>
@@ -3562,7 +3562,7 @@
         </p:nvSpPr>
         <p:spPr>
           <a:xfrm>
-            <a:off x="2011680" y="1719072"/>
+            <a:off x="2011680" y="1700784"/>
             <a:ext cx="1243584" cy="219456"/>
           </a:xfrm>
           <a:prstGeom prst="rect">
@@ -3601,7 +3601,7 @@
         </p:nvSpPr>
         <p:spPr>
           <a:xfrm>
-            <a:off x="3328416" y="1719072"/>
+            <a:off x="3328416" y="1700784"/>
             <a:ext cx="1243584" cy="219456"/>
           </a:xfrm>
           <a:prstGeom prst="rect">
@@ -3640,7 +3640,7 @@
         </p:nvSpPr>
         <p:spPr>
           <a:xfrm>
-            <a:off x="4645152" y="1719072"/>
+            <a:off x="4645152" y="1700784"/>
             <a:ext cx="1243584" cy="219456"/>
           </a:xfrm>
           <a:prstGeom prst="rect">
@@ -3679,7 +3679,7 @@
         </p:nvSpPr>
         <p:spPr>
           <a:xfrm>
-            <a:off x="5961888" y="1719072"/>
+            <a:off x="5961888" y="1700784"/>
             <a:ext cx="1243584" cy="219456"/>
           </a:xfrm>
           <a:prstGeom prst="rect">
@@ -3718,7 +3718,7 @@
         </p:nvSpPr>
         <p:spPr>
           <a:xfrm>
-            <a:off x="7278624" y="1719072"/>
+            <a:off x="7278624" y="1700784"/>
             <a:ext cx="932688" cy="219456"/>
           </a:xfrm>
           <a:prstGeom prst="rect">
@@ -3757,7 +3757,7 @@
         </p:nvSpPr>
         <p:spPr>
           <a:xfrm>
-            <a:off x="2011680" y="1975104"/>
+            <a:off x="2011680" y="1947672"/>
             <a:ext cx="5193792" cy="0"/>
           </a:xfrm>
           <a:prstGeom prst="line">
@@ -3775,14 +3775,39 @@
       </p:sp>
       <p:sp>
         <p:nvSpPr>
-          <p:cNvPr id="17" name="Text 15"/>
-          <p:cNvSpPr/>
-          <p:nvPr/>
-        </p:nvSpPr>
-        <p:spPr>
-          <a:xfrm>
-            <a:off x="658368" y="2157984"/>
-            <a:ext cx="1325880" cy="274320"/>
+          <p:cNvPr id="17" name="Shape 15"/>
+          <p:cNvSpPr/>
+          <p:nvPr/>
+        </p:nvSpPr>
+        <p:spPr>
+          <a:xfrm>
+            <a:off x="621792" y="2139696"/>
+            <a:ext cx="45720" cy="877824"/>
+          </a:xfrm>
+          <a:prstGeom prst="rect">
+            <a:avLst/>
+          </a:prstGeom>
+          <a:solidFill>
+            <a:srgbClr val="1428A0"/>
+          </a:solidFill>
+          <a:ln w="12700">
+            <a:solidFill>
+              <a:srgbClr val="1428A0"/>
+            </a:solidFill>
+            <a:prstDash val="solid"/>
+          </a:ln>
+        </p:spPr>
+      </p:sp>
+      <p:sp>
+        <p:nvSpPr>
+          <p:cNvPr id="18" name="Text 16"/>
+          <p:cNvSpPr/>
+          <p:nvPr/>
+        </p:nvSpPr>
+        <p:spPr>
+          <a:xfrm>
+            <a:off x="749808" y="2139696"/>
+            <a:ext cx="1216152" cy="274320"/>
           </a:xfrm>
           <a:prstGeom prst="rect">
             <a:avLst/>
@@ -3814,14 +3839,14 @@
       </p:sp>
       <p:sp>
         <p:nvSpPr>
-          <p:cNvPr id="18" name="Text 16"/>
-          <p:cNvSpPr/>
-          <p:nvPr/>
-        </p:nvSpPr>
-        <p:spPr>
-          <a:xfrm>
-            <a:off x="658368" y="2432304"/>
-            <a:ext cx="1298448" cy="548640"/>
+          <p:cNvPr id="19" name="Text 17"/>
+          <p:cNvSpPr/>
+          <p:nvPr/>
+        </p:nvSpPr>
+        <p:spPr>
+          <a:xfrm>
+            <a:off x="749808" y="2414016"/>
+            <a:ext cx="1188720" cy="649224"/>
           </a:xfrm>
           <a:prstGeom prst="rect">
             <a:avLst/>
@@ -3845,7 +3870,7 @@
                 <a:ea typeface="Segoe UI" pitchFamily="34" charset="-122"/>
                 <a:cs typeface="Segoe UI" pitchFamily="34" charset="-120"/>
               </a:rPr>
-              <a:t>a real recording: the request is corrected twice</a:t>
+              <a:t>a real recording, corrected twice</a:t>
             </a:r>
             <a:endParaRPr lang="en-US" sz="850" dirty="0"/>
           </a:p>
@@ -3853,18 +3878,18 @@
       </p:sp>
       <p:sp>
         <p:nvSpPr>
-          <p:cNvPr id="19" name="Shape 17"/>
-          <p:cNvSpPr/>
-          <p:nvPr/>
-        </p:nvSpPr>
-        <p:spPr>
-          <a:xfrm>
-            <a:off x="2011680" y="2084832"/>
-            <a:ext cx="1243584" cy="932688"/>
+          <p:cNvPr id="20" name="Shape 18"/>
+          <p:cNvSpPr/>
+          <p:nvPr/>
+        </p:nvSpPr>
+        <p:spPr>
+          <a:xfrm>
+            <a:off x="2011680" y="2048256"/>
+            <a:ext cx="1243584" cy="1060704"/>
           </a:xfrm>
           <a:prstGeom prst="roundRect">
             <a:avLst>
-              <a:gd name="adj" fmla="val 5882"/>
+              <a:gd name="adj" fmla="val 5172"/>
             </a:avLst>
           </a:prstGeom>
           <a:solidFill>
@@ -3880,14 +3905,14 @@
       </p:sp>
       <p:sp>
         <p:nvSpPr>
-          <p:cNvPr id="20" name="Text 18"/>
-          <p:cNvSpPr/>
-          <p:nvPr/>
-        </p:nvSpPr>
-        <p:spPr>
-          <a:xfrm>
-            <a:off x="2103120" y="2157984"/>
-            <a:ext cx="1060704" cy="457200"/>
+          <p:cNvPr id="21" name="Text 19"/>
+          <p:cNvSpPr/>
+          <p:nvPr/>
+        </p:nvSpPr>
+        <p:spPr>
+          <a:xfrm>
+            <a:off x="2103120" y="2103120"/>
+            <a:ext cx="1060704" cy="384048"/>
           </a:xfrm>
           <a:prstGeom prst="rect">
             <a:avLst/>
@@ -3917,16 +3942,40 @@
           </a:p>
         </p:txBody>
       </p:sp>
-      <p:sp>
-        <p:nvSpPr>
-          <p:cNvPr id="21" name="Text 19"/>
-          <p:cNvSpPr/>
-          <p:nvPr/>
-        </p:nvSpPr>
-        <p:spPr>
-          <a:xfrm>
-            <a:off x="2103120" y="2633472"/>
-            <a:ext cx="1060704" cy="146304"/>
+      <p:pic>
+        <p:nvPicPr>
+          <p:cNvPr id="22" name="Image 0" descr="frames\wave1.png">    </p:cNvPr>
+          <p:cNvPicPr>
+            <a:picLocks noChangeAspect="1"/>
+          </p:cNvPicPr>
+          <p:nvPr/>
+        </p:nvPicPr>
+        <p:blipFill>
+          <a:blip r:embed="rId1"/>
+          <a:stretch>
+            <a:fillRect/>
+          </a:stretch>
+        </p:blipFill>
+        <p:spPr>
+          <a:xfrm>
+            <a:off x="2103120" y="2505456"/>
+            <a:ext cx="1060704" cy="201168"/>
+          </a:xfrm>
+          <a:prstGeom prst="rect">
+            <a:avLst/>
+          </a:prstGeom>
+        </p:spPr>
+      </p:pic>
+      <p:sp>
+        <p:nvSpPr>
+          <p:cNvPr id="23" name="Text 20"/>
+          <p:cNvSpPr/>
+          <p:nvPr/>
+        </p:nvSpPr>
+        <p:spPr>
+          <a:xfrm>
+            <a:off x="2103120" y="2761488"/>
+            <a:ext cx="1060704" cy="128016"/>
           </a:xfrm>
           <a:prstGeom prst="rect">
             <a:avLst/>
@@ -3958,13 +4007,13 @@
       </p:sp>
       <p:sp>
         <p:nvSpPr>
-          <p:cNvPr id="22" name="Text 20"/>
-          <p:cNvSpPr/>
-          <p:nvPr/>
-        </p:nvSpPr>
-        <p:spPr>
-          <a:xfrm>
-            <a:off x="2103120" y="2770632"/>
+          <p:cNvPr id="24" name="Text 21"/>
+          <p:cNvSpPr/>
+          <p:nvPr/>
+        </p:nvSpPr>
+        <p:spPr>
+          <a:xfrm>
+            <a:off x="2103120" y="2871216"/>
             <a:ext cx="1060704" cy="201168"/>
           </a:xfrm>
           <a:prstGeom prst="rect">
@@ -3997,18 +4046,18 @@
       </p:sp>
       <p:sp>
         <p:nvSpPr>
-          <p:cNvPr id="23" name="Shape 21"/>
-          <p:cNvSpPr/>
-          <p:nvPr/>
-        </p:nvSpPr>
-        <p:spPr>
-          <a:xfrm>
-            <a:off x="3328416" y="2084832"/>
-            <a:ext cx="1243584" cy="932688"/>
+          <p:cNvPr id="25" name="Shape 22"/>
+          <p:cNvSpPr/>
+          <p:nvPr/>
+        </p:nvSpPr>
+        <p:spPr>
+          <a:xfrm>
+            <a:off x="3328416" y="2048256"/>
+            <a:ext cx="1243584" cy="1060704"/>
           </a:xfrm>
           <a:prstGeom prst="roundRect">
             <a:avLst>
-              <a:gd name="adj" fmla="val 5882"/>
+              <a:gd name="adj" fmla="val 5172"/>
             </a:avLst>
           </a:prstGeom>
           <a:solidFill>
@@ -4024,14 +4073,14 @@
       </p:sp>
       <p:sp>
         <p:nvSpPr>
-          <p:cNvPr id="24" name="Text 22"/>
-          <p:cNvSpPr/>
-          <p:nvPr/>
-        </p:nvSpPr>
-        <p:spPr>
-          <a:xfrm>
-            <a:off x="3419856" y="2157984"/>
-            <a:ext cx="1060704" cy="457200"/>
+          <p:cNvPr id="26" name="Text 23"/>
+          <p:cNvSpPr/>
+          <p:nvPr/>
+        </p:nvSpPr>
+        <p:spPr>
+          <a:xfrm>
+            <a:off x="3419856" y="2103120"/>
+            <a:ext cx="1060704" cy="384048"/>
           </a:xfrm>
           <a:prstGeom prst="rect">
             <a:avLst/>
@@ -4061,16 +4110,40 @@
           </a:p>
         </p:txBody>
       </p:sp>
-      <p:sp>
-        <p:nvSpPr>
-          <p:cNvPr id="25" name="Text 23"/>
-          <p:cNvSpPr/>
-          <p:nvPr/>
-        </p:nvSpPr>
-        <p:spPr>
-          <a:xfrm>
-            <a:off x="3419856" y="2633472"/>
-            <a:ext cx="1060704" cy="146304"/>
+      <p:pic>
+        <p:nvPicPr>
+          <p:cNvPr id="27" name="Image 1" descr="frames\wave2.png">    </p:cNvPr>
+          <p:cNvPicPr>
+            <a:picLocks noChangeAspect="1"/>
+          </p:cNvPicPr>
+          <p:nvPr/>
+        </p:nvPicPr>
+        <p:blipFill>
+          <a:blip r:embed="rId2"/>
+          <a:stretch>
+            <a:fillRect/>
+          </a:stretch>
+        </p:blipFill>
+        <p:spPr>
+          <a:xfrm>
+            <a:off x="3419856" y="2505456"/>
+            <a:ext cx="1060704" cy="201168"/>
+          </a:xfrm>
+          <a:prstGeom prst="rect">
+            <a:avLst/>
+          </a:prstGeom>
+        </p:spPr>
+      </p:pic>
+      <p:sp>
+        <p:nvSpPr>
+          <p:cNvPr id="28" name="Text 24"/>
+          <p:cNvSpPr/>
+          <p:nvPr/>
+        </p:nvSpPr>
+        <p:spPr>
+          <a:xfrm>
+            <a:off x="3419856" y="2761488"/>
+            <a:ext cx="1060704" cy="128016"/>
           </a:xfrm>
           <a:prstGeom prst="rect">
             <a:avLst/>
@@ -4102,13 +4175,13 @@
       </p:sp>
       <p:sp>
         <p:nvSpPr>
-          <p:cNvPr id="26" name="Text 24"/>
-          <p:cNvSpPr/>
-          <p:nvPr/>
-        </p:nvSpPr>
-        <p:spPr>
-          <a:xfrm>
-            <a:off x="3419856" y="2770632"/>
+          <p:cNvPr id="29" name="Text 25"/>
+          <p:cNvSpPr/>
+          <p:nvPr/>
+        </p:nvSpPr>
+        <p:spPr>
+          <a:xfrm>
+            <a:off x="3419856" y="2871216"/>
             <a:ext cx="1060704" cy="201168"/>
           </a:xfrm>
           <a:prstGeom prst="rect">
@@ -4155,18 +4228,18 @@
       </p:sp>
       <p:sp>
         <p:nvSpPr>
-          <p:cNvPr id="27" name="Shape 25"/>
-          <p:cNvSpPr/>
-          <p:nvPr/>
-        </p:nvSpPr>
-        <p:spPr>
-          <a:xfrm>
-            <a:off x="4645152" y="2084832"/>
-            <a:ext cx="1243584" cy="932688"/>
+          <p:cNvPr id="30" name="Shape 26"/>
+          <p:cNvSpPr/>
+          <p:nvPr/>
+        </p:nvSpPr>
+        <p:spPr>
+          <a:xfrm>
+            <a:off x="4645152" y="2048256"/>
+            <a:ext cx="1243584" cy="1060704"/>
           </a:xfrm>
           <a:prstGeom prst="roundRect">
             <a:avLst>
-              <a:gd name="adj" fmla="val 5882"/>
+              <a:gd name="adj" fmla="val 5172"/>
             </a:avLst>
           </a:prstGeom>
           <a:solidFill>
@@ -4182,14 +4255,14 @@
       </p:sp>
       <p:sp>
         <p:nvSpPr>
-          <p:cNvPr id="28" name="Text 26"/>
-          <p:cNvSpPr/>
-          <p:nvPr/>
-        </p:nvSpPr>
-        <p:spPr>
-          <a:xfrm>
-            <a:off x="4736592" y="2157984"/>
-            <a:ext cx="1060704" cy="457200"/>
+          <p:cNvPr id="31" name="Text 27"/>
+          <p:cNvSpPr/>
+          <p:nvPr/>
+        </p:nvSpPr>
+        <p:spPr>
+          <a:xfrm>
+            <a:off x="4736592" y="2103120"/>
+            <a:ext cx="1060704" cy="384048"/>
           </a:xfrm>
           <a:prstGeom prst="rect">
             <a:avLst/>
@@ -4219,16 +4292,40 @@
           </a:p>
         </p:txBody>
       </p:sp>
-      <p:sp>
-        <p:nvSpPr>
-          <p:cNvPr id="29" name="Text 27"/>
-          <p:cNvSpPr/>
-          <p:nvPr/>
-        </p:nvSpPr>
-        <p:spPr>
-          <a:xfrm>
-            <a:off x="4736592" y="2633472"/>
-            <a:ext cx="1060704" cy="146304"/>
+      <p:pic>
+        <p:nvPicPr>
+          <p:cNvPr id="32" name="Image 2" descr="frames\wave3.png">    </p:cNvPr>
+          <p:cNvPicPr>
+            <a:picLocks noChangeAspect="1"/>
+          </p:cNvPicPr>
+          <p:nvPr/>
+        </p:nvPicPr>
+        <p:blipFill>
+          <a:blip r:embed="rId3"/>
+          <a:stretch>
+            <a:fillRect/>
+          </a:stretch>
+        </p:blipFill>
+        <p:spPr>
+          <a:xfrm>
+            <a:off x="4736592" y="2505456"/>
+            <a:ext cx="1060704" cy="201168"/>
+          </a:xfrm>
+          <a:prstGeom prst="rect">
+            <a:avLst/>
+          </a:prstGeom>
+        </p:spPr>
+      </p:pic>
+      <p:sp>
+        <p:nvSpPr>
+          <p:cNvPr id="33" name="Text 28"/>
+          <p:cNvSpPr/>
+          <p:nvPr/>
+        </p:nvSpPr>
+        <p:spPr>
+          <a:xfrm>
+            <a:off x="4736592" y="2761488"/>
+            <a:ext cx="1060704" cy="128016"/>
           </a:xfrm>
           <a:prstGeom prst="rect">
             <a:avLst/>
@@ -4260,13 +4357,13 @@
       </p:sp>
       <p:sp>
         <p:nvSpPr>
-          <p:cNvPr id="30" name="Text 28"/>
-          <p:cNvSpPr/>
-          <p:nvPr/>
-        </p:nvSpPr>
-        <p:spPr>
-          <a:xfrm>
-            <a:off x="4736592" y="2770632"/>
+          <p:cNvPr id="34" name="Text 29"/>
+          <p:cNvSpPr/>
+          <p:nvPr/>
+        </p:nvSpPr>
+        <p:spPr>
+          <a:xfrm>
+            <a:off x="4736592" y="2871216"/>
             <a:ext cx="1060704" cy="201168"/>
           </a:xfrm>
           <a:prstGeom prst="rect">
@@ -4299,18 +4396,18 @@
       </p:sp>
       <p:sp>
         <p:nvSpPr>
-          <p:cNvPr id="31" name="Shape 29"/>
-          <p:cNvSpPr/>
-          <p:nvPr/>
-        </p:nvSpPr>
-        <p:spPr>
-          <a:xfrm>
-            <a:off x="5961888" y="2084832"/>
-            <a:ext cx="1243584" cy="932688"/>
+          <p:cNvPr id="35" name="Shape 30"/>
+          <p:cNvSpPr/>
+          <p:nvPr/>
+        </p:nvSpPr>
+        <p:spPr>
+          <a:xfrm>
+            <a:off x="5961888" y="2048256"/>
+            <a:ext cx="1243584" cy="1060704"/>
           </a:xfrm>
           <a:prstGeom prst="roundRect">
             <a:avLst>
-              <a:gd name="adj" fmla="val 5882"/>
+              <a:gd name="adj" fmla="val 5172"/>
             </a:avLst>
           </a:prstGeom>
           <a:solidFill>
@@ -4326,14 +4423,14 @@
       </p:sp>
       <p:sp>
         <p:nvSpPr>
-          <p:cNvPr id="32" name="Text 30"/>
-          <p:cNvSpPr/>
-          <p:nvPr/>
-        </p:nvSpPr>
-        <p:spPr>
-          <a:xfrm>
-            <a:off x="6053328" y="2157984"/>
-            <a:ext cx="1060704" cy="457200"/>
+          <p:cNvPr id="36" name="Text 31"/>
+          <p:cNvSpPr/>
+          <p:nvPr/>
+        </p:nvSpPr>
+        <p:spPr>
+          <a:xfrm>
+            <a:off x="6053328" y="2103120"/>
+            <a:ext cx="1060704" cy="384048"/>
           </a:xfrm>
           <a:prstGeom prst="rect">
             <a:avLst/>
@@ -4363,16 +4460,40 @@
           </a:p>
         </p:txBody>
       </p:sp>
-      <p:sp>
-        <p:nvSpPr>
-          <p:cNvPr id="33" name="Text 31"/>
-          <p:cNvSpPr/>
-          <p:nvPr/>
-        </p:nvSpPr>
-        <p:spPr>
-          <a:xfrm>
-            <a:off x="6053328" y="2633472"/>
-            <a:ext cx="1060704" cy="146304"/>
+      <p:pic>
+        <p:nvPicPr>
+          <p:cNvPr id="37" name="Image 3" descr="frames\wave4.png">    </p:cNvPr>
+          <p:cNvPicPr>
+            <a:picLocks noChangeAspect="1"/>
+          </p:cNvPicPr>
+          <p:nvPr/>
+        </p:nvPicPr>
+        <p:blipFill>
+          <a:blip r:embed="rId4"/>
+          <a:stretch>
+            <a:fillRect/>
+          </a:stretch>
+        </p:blipFill>
+        <p:spPr>
+          <a:xfrm>
+            <a:off x="6053328" y="2505456"/>
+            <a:ext cx="1060704" cy="201168"/>
+          </a:xfrm>
+          <a:prstGeom prst="rect">
+            <a:avLst/>
+          </a:prstGeom>
+        </p:spPr>
+      </p:pic>
+      <p:sp>
+        <p:nvSpPr>
+          <p:cNvPr id="38" name="Text 32"/>
+          <p:cNvSpPr/>
+          <p:nvPr/>
+        </p:nvSpPr>
+        <p:spPr>
+          <a:xfrm>
+            <a:off x="6053328" y="2761488"/>
+            <a:ext cx="1060704" cy="128016"/>
           </a:xfrm>
           <a:prstGeom prst="rect">
             <a:avLst/>
@@ -4404,13 +4525,13 @@
       </p:sp>
       <p:sp>
         <p:nvSpPr>
-          <p:cNvPr id="34" name="Text 32"/>
-          <p:cNvSpPr/>
-          <p:nvPr/>
-        </p:nvSpPr>
-        <p:spPr>
-          <a:xfrm>
-            <a:off x="6053328" y="2770632"/>
+          <p:cNvPr id="39" name="Text 33"/>
+          <p:cNvSpPr/>
+          <p:nvPr/>
+        </p:nvSpPr>
+        <p:spPr>
+          <a:xfrm>
+            <a:off x="6053328" y="2871216"/>
             <a:ext cx="1060704" cy="201168"/>
           </a:xfrm>
           <a:prstGeom prst="rect">
@@ -4457,14 +4578,14 @@
       </p:sp>
       <p:sp>
         <p:nvSpPr>
-          <p:cNvPr id="35" name="Shape 33"/>
-          <p:cNvSpPr/>
-          <p:nvPr/>
-        </p:nvSpPr>
-        <p:spPr>
-          <a:xfrm>
-            <a:off x="7278624" y="2084832"/>
-            <a:ext cx="932688" cy="932688"/>
+          <p:cNvPr id="40" name="Shape 34"/>
+          <p:cNvSpPr/>
+          <p:nvPr/>
+        </p:nvSpPr>
+        <p:spPr>
+          <a:xfrm>
+            <a:off x="7278624" y="2048256"/>
+            <a:ext cx="932688" cy="1060704"/>
           </a:xfrm>
           <a:prstGeom prst="roundRect">
             <a:avLst>
@@ -4484,14 +4605,14 @@
       </p:sp>
       <p:sp>
         <p:nvSpPr>
-          <p:cNvPr id="36" name="Text 34"/>
-          <p:cNvSpPr/>
-          <p:nvPr/>
-        </p:nvSpPr>
-        <p:spPr>
-          <a:xfrm>
-            <a:off x="7351776" y="2194560"/>
-            <a:ext cx="786384" cy="201168"/>
+          <p:cNvPr id="41" name="Text 35"/>
+          <p:cNvSpPr/>
+          <p:nvPr/>
+        </p:nvSpPr>
+        <p:spPr>
+          <a:xfrm>
+            <a:off x="7333488" y="2176272"/>
+            <a:ext cx="822960" cy="201168"/>
           </a:xfrm>
           <a:prstGeom prst="rect">
             <a:avLst/>
@@ -4523,14 +4644,14 @@
       </p:sp>
       <p:sp>
         <p:nvSpPr>
-          <p:cNvPr id="37" name="Text 35"/>
-          <p:cNvSpPr/>
-          <p:nvPr/>
-        </p:nvSpPr>
-        <p:spPr>
-          <a:xfrm>
-            <a:off x="7351776" y="2414016"/>
-            <a:ext cx="786384" cy="457200"/>
+          <p:cNvPr id="42" name="Text 36"/>
+          <p:cNvSpPr/>
+          <p:nvPr/>
+        </p:nvSpPr>
+        <p:spPr>
+          <a:xfrm>
+            <a:off x="7333488" y="2414016"/>
+            <a:ext cx="822960" cy="502920"/>
           </a:xfrm>
           <a:prstGeom prst="rect">
             <a:avLst/>
@@ -4546,7 +4667,7 @@
               <a:buNone/>
             </a:pPr>
             <a:r>
-              <a:rPr lang="en-US" sz="1150" dirty="0">
+              <a:rPr lang="en-US" sz="1200" dirty="0">
                 <a:solidFill>
                   <a:srgbClr val="1428A0"/>
                 </a:solidFill>
@@ -4556,14 +4677,14 @@
               </a:rPr>
               <a:t>Milan</a:t>
             </a:r>
-            <a:endParaRPr lang="en-US" sz="1150" dirty="0"/>
+            <a:endParaRPr lang="en-US" sz="1200" dirty="0"/>
           </a:p>
           <a:p>
             <a:pPr algn="ctr" indent="0" marL="0">
               <a:buNone/>
             </a:pPr>
             <a:r>
-              <a:rPr lang="en-US" sz="1150" dirty="0">
+              <a:rPr lang="en-US" sz="1200" dirty="0">
                 <a:solidFill>
                   <a:srgbClr val="1428A0"/>
                 </a:solidFill>
@@ -4573,20 +4694,45 @@
               </a:rPr>
               <a:t>June 3</a:t>
             </a:r>
-            <a:endParaRPr lang="en-US" sz="1150" dirty="0"/>
-          </a:p>
-        </p:txBody>
-      </p:sp>
-      <p:sp>
-        <p:nvSpPr>
-          <p:cNvPr id="38" name="Text 36"/>
-          <p:cNvSpPr/>
-          <p:nvPr/>
-        </p:nvSpPr>
-        <p:spPr>
-          <a:xfrm>
-            <a:off x="658368" y="3182112"/>
-            <a:ext cx="1325880" cy="274320"/>
+            <a:endParaRPr lang="en-US" sz="1200" dirty="0"/>
+          </a:p>
+        </p:txBody>
+      </p:sp>
+      <p:sp>
+        <p:nvSpPr>
+          <p:cNvPr id="43" name="Shape 37"/>
+          <p:cNvSpPr/>
+          <p:nvPr/>
+        </p:nvSpPr>
+        <p:spPr>
+          <a:xfrm>
+            <a:off x="621792" y="3273552"/>
+            <a:ext cx="45720" cy="640080"/>
+          </a:xfrm>
+          <a:prstGeom prst="rect">
+            <a:avLst/>
+          </a:prstGeom>
+          <a:solidFill>
+            <a:srgbClr val="C73A3A"/>
+          </a:solidFill>
+          <a:ln w="12700">
+            <a:solidFill>
+              <a:srgbClr val="C73A3A"/>
+            </a:solidFill>
+            <a:prstDash val="solid"/>
+          </a:ln>
+        </p:spPr>
+      </p:sp>
+      <p:sp>
+        <p:nvSpPr>
+          <p:cNvPr id="44" name="Text 38"/>
+          <p:cNvSpPr/>
+          <p:nvPr/>
+        </p:nvSpPr>
+        <p:spPr>
+          <a:xfrm>
+            <a:off x="749808" y="3273552"/>
+            <a:ext cx="1216152" cy="274320"/>
           </a:xfrm>
           <a:prstGeom prst="rect">
             <a:avLst/>
@@ -4610,7 +4756,7 @@
                 <a:ea typeface="Segoe UI Semibold" pitchFamily="34" charset="-122"/>
                 <a:cs typeface="Segoe UI Semibold" pitchFamily="34" charset="-120"/>
               </a:rPr>
-              <a:t>Acts at every pause</a:t>
+              <a:t>Greedy agent</a:t>
             </a:r>
             <a:endParaRPr lang="en-US" sz="1150" dirty="0"/>
           </a:p>
@@ -4618,14 +4764,14 @@
       </p:sp>
       <p:sp>
         <p:nvSpPr>
-          <p:cNvPr id="39" name="Text 37"/>
-          <p:cNvSpPr/>
-          <p:nvPr/>
-        </p:nvSpPr>
-        <p:spPr>
-          <a:xfrm>
-            <a:off x="658368" y="3456432"/>
-            <a:ext cx="1298448" cy="457200"/>
+          <p:cNvPr id="45" name="Text 39"/>
+          <p:cNvSpPr/>
+          <p:nvPr/>
+        </p:nvSpPr>
+        <p:spPr>
+          <a:xfrm>
+            <a:off x="749808" y="3547872"/>
+            <a:ext cx="1188720" cy="411480"/>
           </a:xfrm>
           <a:prstGeom prst="rect">
             <a:avLst/>
@@ -4649,7 +4795,7 @@
                 <a:ea typeface="Segoe UI" pitchFamily="34" charset="-122"/>
                 <a:cs typeface="Segoe UI" pitchFamily="34" charset="-120"/>
               </a:rPr>
-              <a:t>what acting at each turn end would call</a:t>
+              <a:t>what acting at every turn end would call</a:t>
             </a:r>
             <a:endParaRPr lang="en-US" sz="850" dirty="0"/>
           </a:p>
@@ -4657,26 +4803,26 @@
       </p:sp>
       <p:sp>
         <p:nvSpPr>
-          <p:cNvPr id="40" name="Shape 38"/>
-          <p:cNvSpPr/>
-          <p:nvPr/>
-        </p:nvSpPr>
-        <p:spPr>
-          <a:xfrm>
-            <a:off x="2011680" y="3108960"/>
-            <a:ext cx="1243584" cy="841248"/>
+          <p:cNvPr id="46" name="Shape 40"/>
+          <p:cNvSpPr/>
+          <p:nvPr/>
+        </p:nvSpPr>
+        <p:spPr>
+          <a:xfrm>
+            <a:off x="2011680" y="3182112"/>
+            <a:ext cx="1243584" cy="822960"/>
           </a:xfrm>
           <a:prstGeom prst="roundRect">
             <a:avLst>
-              <a:gd name="adj" fmla="val 6522"/>
+              <a:gd name="adj" fmla="val 6667"/>
             </a:avLst>
           </a:prstGeom>
           <a:solidFill>
-            <a:srgbClr val="E9EDF5"/>
+            <a:srgbClr val="FFFFFF"/>
           </a:solidFill>
           <a:ln w="12700">
             <a:solidFill>
-              <a:srgbClr val="E9EDF5"/>
+              <a:srgbClr val="E7EBF2"/>
             </a:solidFill>
             <a:prstDash val="solid"/>
           </a:ln>
@@ -4684,14 +4830,14 @@
       </p:sp>
       <p:sp>
         <p:nvSpPr>
-          <p:cNvPr id="41" name="Text 39"/>
-          <p:cNvSpPr/>
-          <p:nvPr/>
-        </p:nvSpPr>
-        <p:spPr>
-          <a:xfrm>
-            <a:off x="2011680" y="3108960"/>
-            <a:ext cx="1243584" cy="841248"/>
+          <p:cNvPr id="47" name="Text 41"/>
+          <p:cNvSpPr/>
+          <p:nvPr/>
+        </p:nvSpPr>
+        <p:spPr>
+          <a:xfrm>
+            <a:off x="2011680" y="3182112"/>
+            <a:ext cx="1243584" cy="822960"/>
           </a:xfrm>
           <a:prstGeom prst="rect">
             <a:avLst/>
@@ -4707,7 +4853,7 @@
               <a:buNone/>
             </a:pPr>
             <a:r>
-              <a:rPr lang="en-US" sz="900" dirty="0">
+              <a:rPr lang="en-US" sz="900" i="1" dirty="0">
                 <a:solidFill>
                   <a:srgbClr val="8791A5"/>
                 </a:solidFill>
@@ -4723,26 +4869,26 @@
       </p:sp>
       <p:sp>
         <p:nvSpPr>
-          <p:cNvPr id="42" name="Shape 40"/>
-          <p:cNvSpPr/>
-          <p:nvPr/>
-        </p:nvSpPr>
-        <p:spPr>
-          <a:xfrm>
-            <a:off x="3328416" y="3108960"/>
-            <a:ext cx="1243584" cy="841248"/>
+          <p:cNvPr id="48" name="Shape 42"/>
+          <p:cNvSpPr/>
+          <p:nvPr/>
+        </p:nvSpPr>
+        <p:spPr>
+          <a:xfrm>
+            <a:off x="3328416" y="3182112"/>
+            <a:ext cx="1243584" cy="822960"/>
           </a:xfrm>
           <a:prstGeom prst="roundRect">
             <a:avLst>
-              <a:gd name="adj" fmla="val 6522"/>
+              <a:gd name="adj" fmla="val 6667"/>
             </a:avLst>
           </a:prstGeom>
           <a:solidFill>
-            <a:srgbClr val="E9EDF5"/>
+            <a:srgbClr val="FFFFFF"/>
           </a:solidFill>
           <a:ln w="12700">
             <a:solidFill>
-              <a:srgbClr val="E9EDF5"/>
+              <a:srgbClr val="E7EBF2"/>
             </a:solidFill>
             <a:prstDash val="solid"/>
           </a:ln>
@@ -4750,14 +4896,14 @@
       </p:sp>
       <p:sp>
         <p:nvSpPr>
-          <p:cNvPr id="43" name="Text 41"/>
-          <p:cNvSpPr/>
-          <p:nvPr/>
-        </p:nvSpPr>
-        <p:spPr>
-          <a:xfrm>
-            <a:off x="3328416" y="3108960"/>
-            <a:ext cx="1243584" cy="841248"/>
+          <p:cNvPr id="49" name="Text 43"/>
+          <p:cNvSpPr/>
+          <p:nvPr/>
+        </p:nvSpPr>
+        <p:spPr>
+          <a:xfrm>
+            <a:off x="3328416" y="3182112"/>
+            <a:ext cx="1243584" cy="822960"/>
           </a:xfrm>
           <a:prstGeom prst="rect">
             <a:avLst/>
@@ -4773,7 +4919,7 @@
               <a:buNone/>
             </a:pPr>
             <a:r>
-              <a:rPr lang="en-US" sz="900" dirty="0">
+              <a:rPr lang="en-US" sz="900" i="1" dirty="0">
                 <a:solidFill>
                   <a:srgbClr val="8791A5"/>
                 </a:solidFill>
@@ -4789,18 +4935,18 @@
       </p:sp>
       <p:sp>
         <p:nvSpPr>
-          <p:cNvPr id="44" name="Shape 42"/>
-          <p:cNvSpPr/>
-          <p:nvPr/>
-        </p:nvSpPr>
-        <p:spPr>
-          <a:xfrm>
-            <a:off x="4645152" y="3108960"/>
-            <a:ext cx="1243584" cy="841248"/>
+          <p:cNvPr id="50" name="Shape 44"/>
+          <p:cNvSpPr/>
+          <p:nvPr/>
+        </p:nvSpPr>
+        <p:spPr>
+          <a:xfrm>
+            <a:off x="4645152" y="3182112"/>
+            <a:ext cx="1243584" cy="822960"/>
           </a:xfrm>
           <a:prstGeom prst="roundRect">
             <a:avLst>
-              <a:gd name="adj" fmla="val 6522"/>
+              <a:gd name="adj" fmla="val 6667"/>
             </a:avLst>
           </a:prstGeom>
           <a:solidFill>
@@ -4816,13 +4962,13 @@
       </p:sp>
       <p:sp>
         <p:nvSpPr>
-          <p:cNvPr id="45" name="Text 43"/>
-          <p:cNvSpPr/>
-          <p:nvPr/>
-        </p:nvSpPr>
-        <p:spPr>
-          <a:xfrm>
-            <a:off x="4718304" y="3200400"/>
+          <p:cNvPr id="51" name="Text 45"/>
+          <p:cNvSpPr/>
+          <p:nvPr/>
+        </p:nvSpPr>
+        <p:spPr>
+          <a:xfrm>
+            <a:off x="4718304" y="3273552"/>
             <a:ext cx="1097280" cy="411480"/>
           </a:xfrm>
           <a:prstGeom prst="rect">
@@ -4872,13 +5018,13 @@
       </p:sp>
       <p:sp>
         <p:nvSpPr>
-          <p:cNvPr id="46" name="Text 44"/>
-          <p:cNvSpPr/>
-          <p:nvPr/>
-        </p:nvSpPr>
-        <p:spPr>
-          <a:xfrm>
-            <a:off x="4645152" y="3639312"/>
+          <p:cNvPr id="52" name="Text 46"/>
+          <p:cNvSpPr/>
+          <p:nvPr/>
+        </p:nvSpPr>
+        <p:spPr>
+          <a:xfrm>
+            <a:off x="4645152" y="3703320"/>
             <a:ext cx="1243584" cy="228600"/>
           </a:xfrm>
           <a:prstGeom prst="rect">
@@ -4911,18 +5057,18 @@
       </p:sp>
       <p:sp>
         <p:nvSpPr>
-          <p:cNvPr id="47" name="Shape 45"/>
-          <p:cNvSpPr/>
-          <p:nvPr/>
-        </p:nvSpPr>
-        <p:spPr>
-          <a:xfrm>
-            <a:off x="5961888" y="3108960"/>
-            <a:ext cx="1243584" cy="841248"/>
+          <p:cNvPr id="53" name="Shape 47"/>
+          <p:cNvSpPr/>
+          <p:nvPr/>
+        </p:nvSpPr>
+        <p:spPr>
+          <a:xfrm>
+            <a:off x="5961888" y="3182112"/>
+            <a:ext cx="1243584" cy="822960"/>
           </a:xfrm>
           <a:prstGeom prst="roundRect">
             <a:avLst>
-              <a:gd name="adj" fmla="val 6522"/>
+              <a:gd name="adj" fmla="val 6667"/>
             </a:avLst>
           </a:prstGeom>
           <a:solidFill>
@@ -4938,13 +5084,13 @@
       </p:sp>
       <p:sp>
         <p:nvSpPr>
-          <p:cNvPr id="48" name="Text 46"/>
-          <p:cNvSpPr/>
-          <p:nvPr/>
-        </p:nvSpPr>
-        <p:spPr>
-          <a:xfrm>
-            <a:off x="6035040" y="3200400"/>
+          <p:cNvPr id="54" name="Text 48"/>
+          <p:cNvSpPr/>
+          <p:nvPr/>
+        </p:nvSpPr>
+        <p:spPr>
+          <a:xfrm>
+            <a:off x="6035040" y="3273552"/>
             <a:ext cx="1097280" cy="411480"/>
           </a:xfrm>
           <a:prstGeom prst="rect">
@@ -4994,13 +5140,13 @@
       </p:sp>
       <p:sp>
         <p:nvSpPr>
-          <p:cNvPr id="49" name="Text 47"/>
-          <p:cNvSpPr/>
-          <p:nvPr/>
-        </p:nvSpPr>
-        <p:spPr>
-          <a:xfrm>
-            <a:off x="5961888" y="3639312"/>
+          <p:cNvPr id="55" name="Text 49"/>
+          <p:cNvSpPr/>
+          <p:nvPr/>
+        </p:nvSpPr>
+        <p:spPr>
+          <a:xfrm>
+            <a:off x="5961888" y="3703320"/>
             <a:ext cx="1243584" cy="228600"/>
           </a:xfrm>
           <a:prstGeom prst="rect">
@@ -5017,7 +5163,7 @@
               <a:buNone/>
             </a:pPr>
             <a:r>
-              <a:rPr lang="en-US" sz="900" dirty="0">
+              <a:rPr lang="en-US" sz="850" dirty="0">
                 <a:solidFill>
                   <a:srgbClr val="4F5B73"/>
                 </a:solidFill>
@@ -5025,26 +5171,26 @@
                 <a:ea typeface="Segoe UI" pitchFamily="34" charset="-122"/>
                 <a:cs typeface="Segoe UI" pitchFamily="34" charset="-120"/>
               </a:rPr>
-              <a:t>right, but too late</a:t>
-            </a:r>
-            <a:endParaRPr lang="en-US" sz="900" dirty="0"/>
-          </a:p>
-        </p:txBody>
-      </p:sp>
-      <p:sp>
-        <p:nvSpPr>
-          <p:cNvPr id="50" name="Shape 48"/>
-          <p:cNvSpPr/>
-          <p:nvPr/>
-        </p:nvSpPr>
-        <p:spPr>
-          <a:xfrm>
-            <a:off x="7278624" y="3108960"/>
-            <a:ext cx="932688" cy="841248"/>
+              <a:t>right, but one too many</a:t>
+            </a:r>
+            <a:endParaRPr lang="en-US" sz="850" dirty="0"/>
+          </a:p>
+        </p:txBody>
+      </p:sp>
+      <p:sp>
+        <p:nvSpPr>
+          <p:cNvPr id="56" name="Shape 50"/>
+          <p:cNvSpPr/>
+          <p:nvPr/>
+        </p:nvSpPr>
+        <p:spPr>
+          <a:xfrm>
+            <a:off x="7278624" y="3182112"/>
+            <a:ext cx="932688" cy="822960"/>
           </a:xfrm>
           <a:prstGeom prst="roundRect">
             <a:avLst>
-              <a:gd name="adj" fmla="val 6522"/>
+              <a:gd name="adj" fmla="val 6667"/>
             </a:avLst>
           </a:prstGeom>
           <a:solidFill>
@@ -5060,14 +5206,14 @@
       </p:sp>
       <p:sp>
         <p:nvSpPr>
-          <p:cNvPr id="51" name="Text 49"/>
-          <p:cNvSpPr/>
-          <p:nvPr/>
-        </p:nvSpPr>
-        <p:spPr>
-          <a:xfrm>
-            <a:off x="7278624" y="3108960"/>
-            <a:ext cx="932688" cy="841248"/>
+          <p:cNvPr id="57" name="Text 51"/>
+          <p:cNvSpPr/>
+          <p:nvPr/>
+        </p:nvSpPr>
+        <p:spPr>
+          <a:xfrm>
+            <a:off x="7278624" y="3182112"/>
+            <a:ext cx="932688" cy="822960"/>
           </a:xfrm>
           <a:prstGeom prst="rect">
             <a:avLst/>
@@ -5116,14 +5262,39 @@
       </p:sp>
       <p:sp>
         <p:nvSpPr>
-          <p:cNvPr id="52" name="Text 50"/>
-          <p:cNvSpPr/>
-          <p:nvPr/>
-        </p:nvSpPr>
-        <p:spPr>
-          <a:xfrm>
-            <a:off x="658368" y="4114800"/>
-            <a:ext cx="1325880" cy="274320"/>
+          <p:cNvPr id="58" name="Shape 52"/>
+          <p:cNvSpPr/>
+          <p:nvPr/>
+        </p:nvSpPr>
+        <p:spPr>
+          <a:xfrm>
+            <a:off x="621792" y="4169664"/>
+            <a:ext cx="45720" cy="713232"/>
+          </a:xfrm>
+          <a:prstGeom prst="rect">
+            <a:avLst/>
+          </a:prstGeom>
+          <a:solidFill>
+            <a:srgbClr val="13804F"/>
+          </a:solidFill>
+          <a:ln w="12700">
+            <a:solidFill>
+              <a:srgbClr val="13804F"/>
+            </a:solidFill>
+            <a:prstDash val="solid"/>
+          </a:ln>
+        </p:spPr>
+      </p:sp>
+      <p:sp>
+        <p:nvSpPr>
+          <p:cNvPr id="59" name="Text 53"/>
+          <p:cNvSpPr/>
+          <p:nvPr/>
+        </p:nvSpPr>
+        <p:spPr>
+          <a:xfrm>
+            <a:off x="749808" y="4169664"/>
+            <a:ext cx="1216152" cy="274320"/>
           </a:xfrm>
           <a:prstGeom prst="rect">
             <a:avLst/>
@@ -5141,7 +5312,7 @@
             <a:r>
               <a:rPr lang="en-US" sz="1150" dirty="0">
                 <a:solidFill>
-                  <a:srgbClr val="1428A0"/>
+                  <a:srgbClr val="0F1C3F"/>
                 </a:solidFill>
                 <a:latin typeface="Segoe UI Semibold" pitchFamily="34" charset="0"/>
                 <a:ea typeface="Segoe UI Semibold" pitchFamily="34" charset="-122"/>
@@ -5155,14 +5326,14 @@
       </p:sp>
       <p:sp>
         <p:nvSpPr>
-          <p:cNvPr id="53" name="Text 51"/>
-          <p:cNvSpPr/>
-          <p:nvPr/>
-        </p:nvSpPr>
-        <p:spPr>
-          <a:xfrm>
-            <a:off x="658368" y="4389120"/>
-            <a:ext cx="1298448" cy="512064"/>
+          <p:cNvPr id="60" name="Text 54"/>
+          <p:cNvSpPr/>
+          <p:nvPr/>
+        </p:nvSpPr>
+        <p:spPr>
+          <a:xfrm>
+            <a:off x="749808" y="4443984"/>
+            <a:ext cx="1188720" cy="484632"/>
           </a:xfrm>
           <a:prstGeom prst="rect">
             <a:avLst/>
@@ -5194,13 +5365,13 @@
       </p:sp>
       <p:sp>
         <p:nvSpPr>
-          <p:cNvPr id="54" name="Shape 52"/>
-          <p:cNvSpPr/>
-          <p:nvPr/>
-        </p:nvSpPr>
-        <p:spPr>
-          <a:xfrm>
-            <a:off x="2011680" y="4041648"/>
+          <p:cNvPr id="61" name="Shape 55"/>
+          <p:cNvSpPr/>
+          <p:nvPr/>
+        </p:nvSpPr>
+        <p:spPr>
+          <a:xfrm>
+            <a:off x="2011680" y="4078224"/>
             <a:ext cx="1243584" cy="896112"/>
           </a:xfrm>
           <a:prstGeom prst="roundRect">
@@ -5209,11 +5380,11 @@
             </a:avLst>
           </a:prstGeom>
           <a:solidFill>
-            <a:srgbClr val="E9EDF5"/>
+            <a:srgbClr val="FFFFFF"/>
           </a:solidFill>
           <a:ln w="12700">
             <a:solidFill>
-              <a:srgbClr val="E9EDF5"/>
+              <a:srgbClr val="E7EBF2"/>
             </a:solidFill>
             <a:prstDash val="solid"/>
           </a:ln>
@@ -5221,13 +5392,13 @@
       </p:sp>
       <p:sp>
         <p:nvSpPr>
-          <p:cNvPr id="55" name="Text 53"/>
-          <p:cNvSpPr/>
-          <p:nvPr/>
-        </p:nvSpPr>
-        <p:spPr>
-          <a:xfrm>
-            <a:off x="2011680" y="4041648"/>
+          <p:cNvPr id="62" name="Text 56"/>
+          <p:cNvSpPr/>
+          <p:nvPr/>
+        </p:nvSpPr>
+        <p:spPr>
+          <a:xfrm>
+            <a:off x="2011680" y="4078224"/>
             <a:ext cx="1243584" cy="896112"/>
           </a:xfrm>
           <a:prstGeom prst="rect">
@@ -5244,7 +5415,7 @@
               <a:buNone/>
             </a:pPr>
             <a:r>
-              <a:rPr lang="en-US" sz="900" dirty="0">
+              <a:rPr lang="en-US" sz="900" i="1" dirty="0">
                 <a:solidFill>
                   <a:srgbClr val="8791A5"/>
                 </a:solidFill>
@@ -5260,13 +5431,13 @@
       </p:sp>
       <p:sp>
         <p:nvSpPr>
-          <p:cNvPr id="56" name="Shape 54"/>
-          <p:cNvSpPr/>
-          <p:nvPr/>
-        </p:nvSpPr>
-        <p:spPr>
-          <a:xfrm>
-            <a:off x="3328416" y="4041648"/>
+          <p:cNvPr id="63" name="Shape 57"/>
+          <p:cNvSpPr/>
+          <p:nvPr/>
+        </p:nvSpPr>
+        <p:spPr>
+          <a:xfrm>
+            <a:off x="3328416" y="4078224"/>
             <a:ext cx="1243584" cy="896112"/>
           </a:xfrm>
           <a:prstGeom prst="roundRect">
@@ -5287,13 +5458,13 @@
       </p:sp>
       <p:sp>
         <p:nvSpPr>
-          <p:cNvPr id="57" name="Text 55"/>
-          <p:cNvSpPr/>
-          <p:nvPr/>
-        </p:nvSpPr>
-        <p:spPr>
-          <a:xfrm>
-            <a:off x="3328416" y="4133088"/>
+          <p:cNvPr id="64" name="Text 58"/>
+          <p:cNvSpPr/>
+          <p:nvPr/>
+        </p:nvSpPr>
+        <p:spPr>
+          <a:xfrm>
+            <a:off x="3328416" y="4169664"/>
             <a:ext cx="1243584" cy="228600"/>
           </a:xfrm>
           <a:prstGeom prst="rect">
@@ -5326,13 +5497,13 @@
       </p:sp>
       <p:sp>
         <p:nvSpPr>
-          <p:cNvPr id="58" name="Text 56"/>
-          <p:cNvSpPr/>
-          <p:nvPr/>
-        </p:nvSpPr>
-        <p:spPr>
-          <a:xfrm>
-            <a:off x="3328416" y="4352544"/>
+          <p:cNvPr id="65" name="Text 59"/>
+          <p:cNvSpPr/>
+          <p:nvPr/>
+        </p:nvSpPr>
+        <p:spPr>
+          <a:xfrm>
+            <a:off x="3328416" y="4389120"/>
             <a:ext cx="1243584" cy="256032"/>
           </a:xfrm>
           <a:prstGeom prst="rect">
@@ -5365,13 +5536,13 @@
       </p:sp>
       <p:sp>
         <p:nvSpPr>
-          <p:cNvPr id="59" name="Text 57"/>
-          <p:cNvSpPr/>
-          <p:nvPr/>
-        </p:nvSpPr>
-        <p:spPr>
-          <a:xfrm>
-            <a:off x="3328416" y="4608576"/>
+          <p:cNvPr id="66" name="Text 60"/>
+          <p:cNvSpPr/>
+          <p:nvPr/>
+        </p:nvSpPr>
+        <p:spPr>
+          <a:xfrm>
+            <a:off x="3328416" y="4645152"/>
             <a:ext cx="1243584" cy="228600"/>
           </a:xfrm>
           <a:prstGeom prst="rect">
@@ -5404,13 +5575,13 @@
       </p:sp>
       <p:sp>
         <p:nvSpPr>
-          <p:cNvPr id="60" name="Shape 58"/>
-          <p:cNvSpPr/>
-          <p:nvPr/>
-        </p:nvSpPr>
-        <p:spPr>
-          <a:xfrm>
-            <a:off x="4645152" y="4041648"/>
+          <p:cNvPr id="67" name="Shape 61"/>
+          <p:cNvSpPr/>
+          <p:nvPr/>
+        </p:nvSpPr>
+        <p:spPr>
+          <a:xfrm>
+            <a:off x="4645152" y="4078224"/>
             <a:ext cx="1243584" cy="896112"/>
           </a:xfrm>
           <a:prstGeom prst="roundRect">
@@ -5431,13 +5602,13 @@
       </p:sp>
       <p:sp>
         <p:nvSpPr>
-          <p:cNvPr id="61" name="Text 59"/>
-          <p:cNvSpPr/>
-          <p:nvPr/>
-        </p:nvSpPr>
-        <p:spPr>
-          <a:xfrm>
-            <a:off x="4645152" y="4133088"/>
+          <p:cNvPr id="68" name="Text 62"/>
+          <p:cNvSpPr/>
+          <p:nvPr/>
+        </p:nvSpPr>
+        <p:spPr>
+          <a:xfrm>
+            <a:off x="4645152" y="4169664"/>
             <a:ext cx="1243584" cy="228600"/>
           </a:xfrm>
           <a:prstGeom prst="rect">
@@ -5470,13 +5641,13 @@
       </p:sp>
       <p:sp>
         <p:nvSpPr>
-          <p:cNvPr id="62" name="Text 60"/>
-          <p:cNvSpPr/>
-          <p:nvPr/>
-        </p:nvSpPr>
-        <p:spPr>
-          <a:xfrm>
-            <a:off x="4645152" y="4352544"/>
+          <p:cNvPr id="69" name="Text 63"/>
+          <p:cNvSpPr/>
+          <p:nvPr/>
+        </p:nvSpPr>
+        <p:spPr>
+          <a:xfrm>
+            <a:off x="4645152" y="4389120"/>
             <a:ext cx="1243584" cy="256032"/>
           </a:xfrm>
           <a:prstGeom prst="rect">
@@ -5509,13 +5680,13 @@
       </p:sp>
       <p:sp>
         <p:nvSpPr>
-          <p:cNvPr id="63" name="Text 61"/>
-          <p:cNvSpPr/>
-          <p:nvPr/>
-        </p:nvSpPr>
-        <p:spPr>
-          <a:xfrm>
-            <a:off x="4645152" y="4608576"/>
+          <p:cNvPr id="70" name="Text 64"/>
+          <p:cNvSpPr/>
+          <p:nvPr/>
+        </p:nvSpPr>
+        <p:spPr>
+          <a:xfrm>
+            <a:off x="4645152" y="4645152"/>
             <a:ext cx="1243584" cy="228600"/>
           </a:xfrm>
           <a:prstGeom prst="rect">
@@ -5548,13 +5719,13 @@
       </p:sp>
       <p:sp>
         <p:nvSpPr>
-          <p:cNvPr id="64" name="Shape 62"/>
-          <p:cNvSpPr/>
-          <p:nvPr/>
-        </p:nvSpPr>
-        <p:spPr>
-          <a:xfrm>
-            <a:off x="5961888" y="4041648"/>
+          <p:cNvPr id="71" name="Shape 65"/>
+          <p:cNvSpPr/>
+          <p:nvPr/>
+        </p:nvSpPr>
+        <p:spPr>
+          <a:xfrm>
+            <a:off x="5961888" y="4078224"/>
             <a:ext cx="1243584" cy="896112"/>
           </a:xfrm>
           <a:prstGeom prst="roundRect">
@@ -5575,13 +5746,13 @@
       </p:sp>
       <p:sp>
         <p:nvSpPr>
-          <p:cNvPr id="65" name="Text 63"/>
-          <p:cNvSpPr/>
-          <p:nvPr/>
-        </p:nvSpPr>
-        <p:spPr>
-          <a:xfrm>
-            <a:off x="5961888" y="4105656"/>
+          <p:cNvPr id="72" name="Text 66"/>
+          <p:cNvSpPr/>
+          <p:nvPr/>
+        </p:nvSpPr>
+        <p:spPr>
+          <a:xfrm>
+            <a:off x="5961888" y="4142232"/>
             <a:ext cx="1243584" cy="201168"/>
           </a:xfrm>
           <a:prstGeom prst="rect">
@@ -5614,13 +5785,13 @@
       </p:sp>
       <p:sp>
         <p:nvSpPr>
-          <p:cNvPr id="66" name="Text 64"/>
-          <p:cNvSpPr/>
-          <p:nvPr/>
-        </p:nvSpPr>
-        <p:spPr>
-          <a:xfrm>
-            <a:off x="6035040" y="4315968"/>
+          <p:cNvPr id="73" name="Text 67"/>
+          <p:cNvSpPr/>
+          <p:nvPr/>
+        </p:nvSpPr>
+        <p:spPr>
+          <a:xfrm>
+            <a:off x="6035040" y="4352544"/>
             <a:ext cx="1097280" cy="384048"/>
           </a:xfrm>
           <a:prstGeom prst="rect">
@@ -5670,13 +5841,13 @@
       </p:sp>
       <p:sp>
         <p:nvSpPr>
-          <p:cNvPr id="67" name="Text 65"/>
-          <p:cNvSpPr/>
-          <p:nvPr/>
-        </p:nvSpPr>
-        <p:spPr>
-          <a:xfrm>
-            <a:off x="5961888" y="4700016"/>
+          <p:cNvPr id="74" name="Text 68"/>
+          <p:cNvSpPr/>
+          <p:nvPr/>
+        </p:nvSpPr>
+        <p:spPr>
+          <a:xfrm>
+            <a:off x="5961888" y="4736592"/>
             <a:ext cx="1243584" cy="201168"/>
           </a:xfrm>
           <a:prstGeom prst="rect">
@@ -5709,13 +5880,13 @@
       </p:sp>
       <p:sp>
         <p:nvSpPr>
-          <p:cNvPr id="68" name="Shape 66"/>
-          <p:cNvSpPr/>
-          <p:nvPr/>
-        </p:nvSpPr>
-        <p:spPr>
-          <a:xfrm>
-            <a:off x="7278624" y="4041648"/>
+          <p:cNvPr id="75" name="Shape 69"/>
+          <p:cNvSpPr/>
+          <p:nvPr/>
+        </p:nvSpPr>
+        <p:spPr>
+          <a:xfrm>
+            <a:off x="7278624" y="4078224"/>
             <a:ext cx="932688" cy="896112"/>
           </a:xfrm>
           <a:prstGeom prst="roundRect">
@@ -5736,13 +5907,13 @@
       </p:sp>
       <p:sp>
         <p:nvSpPr>
-          <p:cNvPr id="69" name="Text 67"/>
-          <p:cNvSpPr/>
-          <p:nvPr/>
-        </p:nvSpPr>
-        <p:spPr>
-          <a:xfrm>
-            <a:off x="7278624" y="4041648"/>
+          <p:cNvPr id="76" name="Text 70"/>
+          <p:cNvSpPr/>
+          <p:nvPr/>
+        </p:nvSpPr>
+        <p:spPr>
+          <a:xfrm>
+            <a:off x="7278624" y="4078224"/>
             <a:ext cx="932688" cy="896112"/>
           </a:xfrm>
           <a:prstGeom prst="rect">
@@ -5792,7 +5963,7 @@
       </p:sp>
       <p:sp>
         <p:nvSpPr>
-          <p:cNvPr id="70" name="Shape 68"/>
+          <p:cNvPr id="77" name="Shape 71"/>
           <p:cNvSpPr/>
           <p:nvPr/>
         </p:nvSpPr>
@@ -5819,7 +5990,7 @@
       </p:sp>
       <p:sp>
         <p:nvSpPr>
-          <p:cNvPr id="71" name="Text 69"/>
+          <p:cNvPr id="78" name="Text 72"/>
           <p:cNvSpPr/>
           <p:nvPr/>
         </p:nvSpPr>
@@ -5858,148 +6029,173 @@
       </p:sp>
       <p:sp>
         <p:nvSpPr>
-          <p:cNvPr id="72" name="Text 70"/>
-          <p:cNvSpPr/>
-          <p:nvPr/>
-        </p:nvSpPr>
-        <p:spPr>
-          <a:xfrm>
-            <a:off x="8668512" y="1920240"/>
-            <a:ext cx="2834640" cy="201168"/>
-          </a:xfrm>
-          <a:prstGeom prst="rect">
-            <a:avLst/>
-          </a:prstGeom>
-          <a:noFill/>
-          <a:ln/>
-        </p:spPr>
-        <p:txBody>
-          <a:bodyPr wrap="square" lIns="0" tIns="0" rIns="0" bIns="0" rtlCol="0" anchor="t"/>
-          <a:lstStyle/>
-          <a:p>
-            <a:pPr indent="0" marL="0">
-              <a:buNone/>
-            </a:pPr>
-            <a:r>
-              <a:rPr lang="en-US" sz="900" dirty="0">
-                <a:solidFill>
-                  <a:srgbClr val="8791A5"/>
+          <p:cNvPr id="79" name="Text 73"/>
+          <p:cNvSpPr/>
+          <p:nvPr/>
+        </p:nvSpPr>
+        <p:spPr>
+          <a:xfrm>
+            <a:off x="8668512" y="1965960"/>
+            <a:ext cx="1417320" cy="685800"/>
+          </a:xfrm>
+          <a:prstGeom prst="rect">
+            <a:avLst/>
+          </a:prstGeom>
+          <a:noFill/>
+          <a:ln/>
+        </p:spPr>
+        <p:txBody>
+          <a:bodyPr wrap="square" lIns="0" tIns="0" rIns="0" bIns="0" rtlCol="0" anchor="t"/>
+          <a:lstStyle/>
+          <a:p>
+            <a:pPr indent="0" marL="0">
+              <a:buNone/>
+            </a:pPr>
+            <a:r>
+              <a:rPr lang="en-US" sz="4000" dirty="0">
+                <a:solidFill>
+                  <a:srgbClr val="1428A0"/>
+                </a:solidFill>
+                <a:latin typeface="Segoe UI Semibold" pitchFamily="34" charset="0"/>
+                <a:ea typeface="Segoe UI Semibold" pitchFamily="34" charset="-122"/>
+                <a:cs typeface="Segoe UI Semibold" pitchFamily="34" charset="-120"/>
+              </a:rPr>
+              <a:t>0.88</a:t>
+            </a:r>
+            <a:endParaRPr lang="en-US" sz="4000" dirty="0"/>
+          </a:p>
+        </p:txBody>
+      </p:sp>
+      <p:sp>
+        <p:nvSpPr>
+          <p:cNvPr id="80" name="Text 74"/>
+          <p:cNvSpPr/>
+          <p:nvPr/>
+        </p:nvSpPr>
+        <p:spPr>
+          <a:xfrm>
+            <a:off x="10104120" y="2103120"/>
+            <a:ext cx="1508760" cy="457200"/>
+          </a:xfrm>
+          <a:prstGeom prst="rect">
+            <a:avLst/>
+          </a:prstGeom>
+          <a:noFill/>
+          <a:ln/>
+        </p:spPr>
+        <p:txBody>
+          <a:bodyPr wrap="square" lIns="0" tIns="0" rIns="0" bIns="0" rtlCol="0" anchor="t"/>
+          <a:lstStyle/>
+          <a:p>
+            <a:pPr indent="0" marL="0">
+              <a:buNone/>
+            </a:pPr>
+            <a:r>
+              <a:rPr lang="en-US" sz="1000" dirty="0">
+                <a:solidFill>
+                  <a:srgbClr val="4F5B73"/>
                 </a:solidFill>
                 <a:latin typeface="Segoe UI" pitchFamily="34" charset="0"/>
                 <a:ea typeface="Segoe UI" pitchFamily="34" charset="-122"/>
                 <a:cs typeface="Segoe UI" pitchFamily="34" charset="-120"/>
               </a:rPr>
-              <a:t>Pass@1, strict</a:t>
-            </a:r>
-            <a:endParaRPr lang="en-US" sz="900" dirty="0"/>
-          </a:p>
-        </p:txBody>
-      </p:sp>
-      <p:sp>
-        <p:nvSpPr>
-          <p:cNvPr id="73" name="Text 71"/>
-          <p:cNvSpPr/>
-          <p:nvPr/>
-        </p:nvSpPr>
-        <p:spPr>
-          <a:xfrm>
-            <a:off x="8668512" y="2121408"/>
-            <a:ext cx="1371600" cy="640080"/>
-          </a:xfrm>
-          <a:prstGeom prst="rect">
-            <a:avLst/>
-          </a:prstGeom>
-          <a:noFill/>
-          <a:ln/>
-        </p:spPr>
-        <p:txBody>
-          <a:bodyPr wrap="square" lIns="0" tIns="0" rIns="0" bIns="0" rtlCol="0" anchor="t"/>
-          <a:lstStyle/>
-          <a:p>
-            <a:pPr indent="0" marL="0">
-              <a:buNone/>
-            </a:pPr>
-            <a:r>
-              <a:rPr lang="en-US" sz="3600" dirty="0">
-                <a:solidFill>
-                  <a:srgbClr val="1428A0"/>
+              <a:t>DUET's Pass@1</a:t>
+            </a:r>
+            <a:endParaRPr lang="en-US" sz="1000" dirty="0"/>
+          </a:p>
+          <a:p>
+            <a:pPr indent="0" marL="0">
+              <a:buNone/>
+            </a:pPr>
+            <a:r>
+              <a:rPr lang="en-US" sz="1000" dirty="0">
+                <a:solidFill>
+                  <a:srgbClr val="4F5B73"/>
+                </a:solidFill>
+                <a:latin typeface="Segoe UI" pitchFamily="34" charset="0"/>
+                <a:ea typeface="Segoe UI" pitchFamily="34" charset="-122"/>
+                <a:cs typeface="Segoe UI" pitchFamily="34" charset="-120"/>
+              </a:rPr>
+              <a:t>15 of 17 items</a:t>
+            </a:r>
+            <a:endParaRPr lang="en-US" sz="1000" dirty="0"/>
+          </a:p>
+        </p:txBody>
+      </p:sp>
+      <p:sp>
+        <p:nvSpPr>
+          <p:cNvPr id="81" name="Text 75"/>
+          <p:cNvSpPr/>
+          <p:nvPr/>
+        </p:nvSpPr>
+        <p:spPr>
+          <a:xfrm>
+            <a:off x="8631936" y="2852928"/>
+            <a:ext cx="1005840" cy="237744"/>
+          </a:xfrm>
+          <a:prstGeom prst="rect">
+            <a:avLst/>
+          </a:prstGeom>
+          <a:noFill/>
+          <a:ln/>
+        </p:spPr>
+        <p:txBody>
+          <a:bodyPr wrap="square" lIns="0" tIns="0" rIns="0" bIns="0" rtlCol="0" anchor="ctr"/>
+          <a:lstStyle/>
+          <a:p>
+            <a:pPr algn="r" indent="0" marL="0">
+              <a:buNone/>
+            </a:pPr>
+            <a:r>
+              <a:rPr lang="en-US" sz="900" dirty="0">
+                <a:solidFill>
+                  <a:srgbClr val="0F1C3F"/>
                 </a:solidFill>
                 <a:latin typeface="Segoe UI Semibold" pitchFamily="34" charset="0"/>
                 <a:ea typeface="Segoe UI Semibold" pitchFamily="34" charset="-122"/>
                 <a:cs typeface="Segoe UI Semibold" pitchFamily="34" charset="-120"/>
               </a:rPr>
-              <a:t>0.88</a:t>
-            </a:r>
-            <a:endParaRPr lang="en-US" sz="3600" dirty="0"/>
-          </a:p>
-        </p:txBody>
-      </p:sp>
-      <p:sp>
-        <p:nvSpPr>
-          <p:cNvPr id="74" name="Text 72"/>
-          <p:cNvSpPr/>
-          <p:nvPr/>
-        </p:nvSpPr>
-        <p:spPr>
-          <a:xfrm>
-            <a:off x="10012680" y="2231136"/>
-            <a:ext cx="1554480" cy="457200"/>
-          </a:xfrm>
-          <a:prstGeom prst="rect">
-            <a:avLst/>
-          </a:prstGeom>
-          <a:noFill/>
-          <a:ln/>
-        </p:spPr>
-        <p:txBody>
-          <a:bodyPr wrap="square" lIns="0" tIns="0" rIns="0" bIns="0" rtlCol="0" anchor="t"/>
-          <a:lstStyle/>
-          <a:p>
-            <a:pPr indent="0" marL="0">
-              <a:buNone/>
-            </a:pPr>
-            <a:r>
-              <a:rPr lang="en-US" sz="1000" dirty="0">
-                <a:solidFill>
-                  <a:srgbClr val="4F5B73"/>
-                </a:solidFill>
-                <a:latin typeface="Segoe UI" pitchFamily="34" charset="0"/>
-                <a:ea typeface="Segoe UI" pitchFamily="34" charset="-122"/>
-                <a:cs typeface="Segoe UI" pitchFamily="34" charset="-120"/>
-              </a:rPr>
               <a:t>DUET</a:t>
             </a:r>
-            <a:endParaRPr lang="en-US" sz="1000" dirty="0"/>
-          </a:p>
-          <a:p>
-            <a:pPr indent="0" marL="0">
-              <a:buNone/>
-            </a:pPr>
-            <a:r>
-              <a:rPr lang="en-US" sz="1000" dirty="0">
-                <a:solidFill>
-                  <a:srgbClr val="4F5B73"/>
-                </a:solidFill>
-                <a:latin typeface="Segoe UI" pitchFamily="34" charset="0"/>
-                <a:ea typeface="Segoe UI" pitchFamily="34" charset="-122"/>
-                <a:cs typeface="Segoe UI" pitchFamily="34" charset="-120"/>
-              </a:rPr>
-              <a:t>15 of 17 items</a:t>
-            </a:r>
-            <a:endParaRPr lang="en-US" sz="1000" dirty="0"/>
-          </a:p>
-        </p:txBody>
-      </p:sp>
-      <p:sp>
-        <p:nvSpPr>
-          <p:cNvPr id="75" name="Shape 73"/>
-          <p:cNvSpPr/>
-          <p:nvPr/>
-        </p:nvSpPr>
-        <p:spPr>
-          <a:xfrm>
-            <a:off x="8668512" y="2852928"/>
-            <a:ext cx="2051914" cy="182880"/>
+            <a:endParaRPr lang="en-US" sz="900" dirty="0"/>
+          </a:p>
+        </p:txBody>
+      </p:sp>
+      <p:sp>
+        <p:nvSpPr>
+          <p:cNvPr id="82" name="Shape 76"/>
+          <p:cNvSpPr/>
+          <p:nvPr/>
+        </p:nvSpPr>
+        <p:spPr>
+          <a:xfrm>
+            <a:off x="9710928" y="2880360"/>
+            <a:ext cx="1417320" cy="182880"/>
+          </a:xfrm>
+          <a:prstGeom prst="rect">
+            <a:avLst/>
+          </a:prstGeom>
+          <a:solidFill>
+            <a:srgbClr val="FFFFFF"/>
+          </a:solidFill>
+          <a:ln w="9525">
+            <a:solidFill>
+              <a:srgbClr val="E7EBF2"/>
+            </a:solidFill>
+            <a:prstDash val="solid"/>
+          </a:ln>
+        </p:spPr>
+      </p:sp>
+      <p:sp>
+        <p:nvSpPr>
+          <p:cNvPr id="83" name="Shape 77"/>
+          <p:cNvSpPr/>
+          <p:nvPr/>
+        </p:nvSpPr>
+        <p:spPr>
+          <a:xfrm>
+            <a:off x="9710928" y="2880360"/>
+            <a:ext cx="1247242" cy="182880"/>
           </a:xfrm>
           <a:prstGeom prst="rect">
             <a:avLst/>
@@ -6017,53 +6213,117 @@
       </p:sp>
       <p:sp>
         <p:nvSpPr>
-          <p:cNvPr id="76" name="Text 74"/>
-          <p:cNvSpPr/>
-          <p:nvPr/>
-        </p:nvSpPr>
-        <p:spPr>
-          <a:xfrm>
-            <a:off x="8668512" y="3054096"/>
-            <a:ext cx="1828800" cy="182880"/>
-          </a:xfrm>
-          <a:prstGeom prst="rect">
-            <a:avLst/>
-          </a:prstGeom>
-          <a:noFill/>
-          <a:ln/>
-        </p:spPr>
-        <p:txBody>
-          <a:bodyPr wrap="square" lIns="0" tIns="0" rIns="0" bIns="0" rtlCol="0" anchor="t"/>
-          <a:lstStyle/>
-          <a:p>
-            <a:pPr indent="0" marL="0">
-              <a:buNone/>
-            </a:pPr>
-            <a:r>
-              <a:rPr lang="en-US" sz="850" dirty="0">
-                <a:solidFill>
-                  <a:srgbClr val="0F1C3F"/>
+          <p:cNvPr id="84" name="Text 78"/>
+          <p:cNvSpPr/>
+          <p:nvPr/>
+        </p:nvSpPr>
+        <p:spPr>
+          <a:xfrm>
+            <a:off x="11173968" y="2852928"/>
+            <a:ext cx="457200" cy="237744"/>
+          </a:xfrm>
+          <a:prstGeom prst="rect">
+            <a:avLst/>
+          </a:prstGeom>
+          <a:noFill/>
+          <a:ln/>
+        </p:spPr>
+        <p:txBody>
+          <a:bodyPr wrap="square" lIns="0" tIns="0" rIns="0" bIns="0" rtlCol="0" anchor="ctr"/>
+          <a:lstStyle/>
+          <a:p>
+            <a:pPr indent="0" marL="0">
+              <a:buNone/>
+            </a:pPr>
+            <a:r>
+              <a:rPr lang="en-US" sz="950" dirty="0">
+                <a:solidFill>
+                  <a:srgbClr val="1428A0"/>
                 </a:solidFill>
                 <a:latin typeface="Segoe UI Semibold" pitchFamily="34" charset="0"/>
                 <a:ea typeface="Segoe UI Semibold" pitchFamily="34" charset="-122"/>
                 <a:cs typeface="Segoe UI Semibold" pitchFamily="34" charset="-120"/>
               </a:rPr>
-              <a:t>DUET</a:t>
-            </a:r>
-            <a:endParaRPr lang="en-US" sz="850" dirty="0"/>
-          </a:p>
-        </p:txBody>
-      </p:sp>
-      <p:sp>
-        <p:nvSpPr>
-          <p:cNvPr id="77" name="Shape 75"/>
-          <p:cNvSpPr/>
-          <p:nvPr/>
-        </p:nvSpPr>
-        <p:spPr>
-          <a:xfrm>
-            <a:off x="8668512" y="3310128"/>
-            <a:ext cx="1371051" cy="182880"/>
+              <a:t>0.88</a:t>
+            </a:r>
+            <a:endParaRPr lang="en-US" sz="950" dirty="0"/>
+          </a:p>
+        </p:txBody>
+      </p:sp>
+      <p:sp>
+        <p:nvSpPr>
+          <p:cNvPr id="85" name="Text 79"/>
+          <p:cNvSpPr/>
+          <p:nvPr/>
+        </p:nvSpPr>
+        <p:spPr>
+          <a:xfrm>
+            <a:off x="8631936" y="3255264"/>
+            <a:ext cx="1005840" cy="237744"/>
+          </a:xfrm>
+          <a:prstGeom prst="rect">
+            <a:avLst/>
+          </a:prstGeom>
+          <a:noFill/>
+          <a:ln/>
+        </p:spPr>
+        <p:txBody>
+          <a:bodyPr wrap="square" lIns="0" tIns="0" rIns="0" bIns="0" rtlCol="0" anchor="ctr"/>
+          <a:lstStyle/>
+          <a:p>
+            <a:pPr algn="r" indent="0" marL="0">
+              <a:buNone/>
+            </a:pPr>
+            <a:r>
+              <a:rPr lang="en-US" sz="900" dirty="0">
+                <a:solidFill>
+                  <a:srgbClr val="4F5B73"/>
+                </a:solidFill>
+                <a:latin typeface="Segoe UI" pitchFamily="34" charset="0"/>
+                <a:ea typeface="Segoe UI" pitchFamily="34" charset="-122"/>
+                <a:cs typeface="Segoe UI" pitchFamily="34" charset="-120"/>
+              </a:rPr>
+              <a:t>GPT-Realtime</a:t>
+            </a:r>
+            <a:endParaRPr lang="en-US" sz="900" dirty="0"/>
+          </a:p>
+        </p:txBody>
+      </p:sp>
+      <p:sp>
+        <p:nvSpPr>
+          <p:cNvPr id="86" name="Shape 80"/>
+          <p:cNvSpPr/>
+          <p:nvPr/>
+        </p:nvSpPr>
+        <p:spPr>
+          <a:xfrm>
+            <a:off x="9710928" y="3282696"/>
+            <a:ext cx="1417320" cy="182880"/>
+          </a:xfrm>
+          <a:prstGeom prst="rect">
+            <a:avLst/>
+          </a:prstGeom>
+          <a:solidFill>
+            <a:srgbClr val="FFFFFF"/>
+          </a:solidFill>
+          <a:ln w="9525">
+            <a:solidFill>
+              <a:srgbClr val="E7EBF2"/>
+            </a:solidFill>
+            <a:prstDash val="solid"/>
+          </a:ln>
+        </p:spPr>
+      </p:sp>
+      <p:sp>
+        <p:nvSpPr>
+          <p:cNvPr id="87" name="Shape 81"/>
+          <p:cNvSpPr/>
+          <p:nvPr/>
+        </p:nvSpPr>
+        <p:spPr>
+          <a:xfrm>
+            <a:off x="9710928" y="3282696"/>
+            <a:ext cx="833384" cy="182880"/>
           </a:xfrm>
           <a:prstGeom prst="rect">
             <a:avLst/>
@@ -6081,23 +6341,23 @@
       </p:sp>
       <p:sp>
         <p:nvSpPr>
-          <p:cNvPr id="78" name="Text 76"/>
-          <p:cNvSpPr/>
-          <p:nvPr/>
-        </p:nvSpPr>
-        <p:spPr>
-          <a:xfrm>
-            <a:off x="10094427" y="3282696"/>
-            <a:ext cx="548640" cy="237744"/>
-          </a:xfrm>
-          <a:prstGeom prst="rect">
-            <a:avLst/>
-          </a:prstGeom>
-          <a:noFill/>
-          <a:ln/>
-        </p:spPr>
-        <p:txBody>
-          <a:bodyPr wrap="square" lIns="0" tIns="0" rIns="0" bIns="0" rtlCol="0" anchor="t"/>
+          <p:cNvPr id="88" name="Text 82"/>
+          <p:cNvSpPr/>
+          <p:nvPr/>
+        </p:nvSpPr>
+        <p:spPr>
+          <a:xfrm>
+            <a:off x="11173968" y="3255264"/>
+            <a:ext cx="457200" cy="237744"/>
+          </a:xfrm>
+          <a:prstGeom prst="rect">
+            <a:avLst/>
+          </a:prstGeom>
+          <a:noFill/>
+          <a:ln/>
+        </p:spPr>
+        <p:txBody>
+          <a:bodyPr wrap="square" lIns="0" tIns="0" rIns="0" bIns="0" rtlCol="0" anchor="ctr"/>
           <a:lstStyle/>
           <a:p>
             <a:pPr indent="0" marL="0">
@@ -6120,30 +6380,30 @@
       </p:sp>
       <p:sp>
         <p:nvSpPr>
-          <p:cNvPr id="79" name="Text 77"/>
-          <p:cNvSpPr/>
-          <p:nvPr/>
-        </p:nvSpPr>
-        <p:spPr>
-          <a:xfrm>
-            <a:off x="8668512" y="3511296"/>
-            <a:ext cx="2194560" cy="182880"/>
-          </a:xfrm>
-          <a:prstGeom prst="rect">
-            <a:avLst/>
-          </a:prstGeom>
-          <a:noFill/>
-          <a:ln/>
-        </p:spPr>
-        <p:txBody>
-          <a:bodyPr wrap="square" lIns="0" tIns="0" rIns="0" bIns="0" rtlCol="0" anchor="t"/>
-          <a:lstStyle/>
-          <a:p>
-            <a:pPr indent="0" marL="0">
-              <a:buNone/>
-            </a:pPr>
-            <a:r>
-              <a:rPr lang="en-US" sz="850" dirty="0">
+          <p:cNvPr id="89" name="Text 83"/>
+          <p:cNvSpPr/>
+          <p:nvPr/>
+        </p:nvSpPr>
+        <p:spPr>
+          <a:xfrm>
+            <a:off x="8631936" y="3657600"/>
+            <a:ext cx="1005840" cy="237744"/>
+          </a:xfrm>
+          <a:prstGeom prst="rect">
+            <a:avLst/>
+          </a:prstGeom>
+          <a:noFill/>
+          <a:ln/>
+        </p:spPr>
+        <p:txBody>
+          <a:bodyPr wrap="square" lIns="0" tIns="0" rIns="0" bIns="0" rtlCol="0" anchor="ctr"/>
+          <a:lstStyle/>
+          <a:p>
+            <a:pPr algn="r" indent="0" marL="0">
+              <a:buNone/>
+            </a:pPr>
+            <a:r>
+              <a:rPr lang="en-US" sz="900" dirty="0">
                 <a:solidFill>
                   <a:srgbClr val="4F5B73"/>
                 </a:solidFill>
@@ -6151,22 +6411,47 @@
                 <a:ea typeface="Segoe UI" pitchFamily="34" charset="-122"/>
                 <a:cs typeface="Segoe UI" pitchFamily="34" charset="-120"/>
               </a:rPr>
-              <a:t>GPT-Realtime</a:t>
-            </a:r>
-            <a:endParaRPr lang="en-US" sz="850" dirty="0"/>
-          </a:p>
-        </p:txBody>
-      </p:sp>
-      <p:sp>
-        <p:nvSpPr>
-          <p:cNvPr id="80" name="Shape 78"/>
-          <p:cNvSpPr/>
-          <p:nvPr/>
-        </p:nvSpPr>
-        <p:spPr>
-          <a:xfrm>
-            <a:off x="8668512" y="3767328"/>
-            <a:ext cx="823097" cy="182880"/>
+              <a:t>Gemini Live 3.1</a:t>
+            </a:r>
+            <a:endParaRPr lang="en-US" sz="900" dirty="0"/>
+          </a:p>
+        </p:txBody>
+      </p:sp>
+      <p:sp>
+        <p:nvSpPr>
+          <p:cNvPr id="90" name="Shape 84"/>
+          <p:cNvSpPr/>
+          <p:nvPr/>
+        </p:nvSpPr>
+        <p:spPr>
+          <a:xfrm>
+            <a:off x="9710928" y="3685032"/>
+            <a:ext cx="1417320" cy="182880"/>
+          </a:xfrm>
+          <a:prstGeom prst="rect">
+            <a:avLst/>
+          </a:prstGeom>
+          <a:solidFill>
+            <a:srgbClr val="FFFFFF"/>
+          </a:solidFill>
+          <a:ln w="9525">
+            <a:solidFill>
+              <a:srgbClr val="E7EBF2"/>
+            </a:solidFill>
+            <a:prstDash val="solid"/>
+          </a:ln>
+        </p:spPr>
+      </p:sp>
+      <p:sp>
+        <p:nvSpPr>
+          <p:cNvPr id="91" name="Shape 85"/>
+          <p:cNvSpPr/>
+          <p:nvPr/>
+        </p:nvSpPr>
+        <p:spPr>
+          <a:xfrm>
+            <a:off x="9710928" y="3685032"/>
+            <a:ext cx="500314" cy="182880"/>
           </a:xfrm>
           <a:prstGeom prst="rect">
             <a:avLst/>
@@ -6184,23 +6469,23 @@
       </p:sp>
       <p:sp>
         <p:nvSpPr>
-          <p:cNvPr id="81" name="Text 79"/>
-          <p:cNvSpPr/>
-          <p:nvPr/>
-        </p:nvSpPr>
-        <p:spPr>
-          <a:xfrm>
-            <a:off x="9546473" y="3739896"/>
-            <a:ext cx="548640" cy="237744"/>
-          </a:xfrm>
-          <a:prstGeom prst="rect">
-            <a:avLst/>
-          </a:prstGeom>
-          <a:noFill/>
-          <a:ln/>
-        </p:spPr>
-        <p:txBody>
-          <a:bodyPr wrap="square" lIns="0" tIns="0" rIns="0" bIns="0" rtlCol="0" anchor="t"/>
+          <p:cNvPr id="92" name="Text 86"/>
+          <p:cNvSpPr/>
+          <p:nvPr/>
+        </p:nvSpPr>
+        <p:spPr>
+          <a:xfrm>
+            <a:off x="11173968" y="3657600"/>
+            <a:ext cx="457200" cy="237744"/>
+          </a:xfrm>
+          <a:prstGeom prst="rect">
+            <a:avLst/>
+          </a:prstGeom>
+          <a:noFill/>
+          <a:ln/>
+        </p:spPr>
+        <p:txBody>
+          <a:bodyPr wrap="square" lIns="0" tIns="0" rIns="0" bIns="0" rtlCol="0" anchor="ctr"/>
           <a:lstStyle/>
           <a:p>
             <a:pPr indent="0" marL="0">
@@ -6223,30 +6508,30 @@
       </p:sp>
       <p:sp>
         <p:nvSpPr>
-          <p:cNvPr id="82" name="Text 80"/>
-          <p:cNvSpPr/>
-          <p:nvPr/>
-        </p:nvSpPr>
-        <p:spPr>
-          <a:xfrm>
-            <a:off x="8668512" y="3968496"/>
-            <a:ext cx="2194560" cy="182880"/>
-          </a:xfrm>
-          <a:prstGeom prst="rect">
-            <a:avLst/>
-          </a:prstGeom>
-          <a:noFill/>
-          <a:ln/>
-        </p:spPr>
-        <p:txBody>
-          <a:bodyPr wrap="square" lIns="0" tIns="0" rIns="0" bIns="0" rtlCol="0" anchor="t"/>
-          <a:lstStyle/>
-          <a:p>
-            <a:pPr indent="0" marL="0">
-              <a:buNone/>
-            </a:pPr>
-            <a:r>
-              <a:rPr lang="en-US" sz="850" dirty="0">
+          <p:cNvPr id="93" name="Text 87"/>
+          <p:cNvSpPr/>
+          <p:nvPr/>
+        </p:nvSpPr>
+        <p:spPr>
+          <a:xfrm>
+            <a:off x="8631936" y="4059936"/>
+            <a:ext cx="1005840" cy="237744"/>
+          </a:xfrm>
+          <a:prstGeom prst="rect">
+            <a:avLst/>
+          </a:prstGeom>
+          <a:noFill/>
+          <a:ln/>
+        </p:spPr>
+        <p:txBody>
+          <a:bodyPr wrap="square" lIns="0" tIns="0" rIns="0" bIns="0" rtlCol="0" anchor="ctr"/>
+          <a:lstStyle/>
+          <a:p>
+            <a:pPr algn="r" indent="0" marL="0">
+              <a:buNone/>
+            </a:pPr>
+            <a:r>
+              <a:rPr lang="en-US" sz="900" dirty="0">
                 <a:solidFill>
                   <a:srgbClr val="4F5B73"/>
                 </a:solidFill>
@@ -6254,22 +6539,47 @@
                 <a:ea typeface="Segoe UI" pitchFamily="34" charset="-122"/>
                 <a:cs typeface="Segoe UI" pitchFamily="34" charset="-120"/>
               </a:rPr>
-              <a:t>Gemini Live 3.1</a:t>
-            </a:r>
-            <a:endParaRPr lang="en-US" sz="850" dirty="0"/>
-          </a:p>
-        </p:txBody>
-      </p:sp>
-      <p:sp>
-        <p:nvSpPr>
-          <p:cNvPr id="83" name="Shape 81"/>
-          <p:cNvSpPr/>
-          <p:nvPr/>
-        </p:nvSpPr>
-        <p:spPr>
-          <a:xfrm>
-            <a:off x="8668512" y="4224528"/>
-            <a:ext cx="410383" cy="182880"/>
+              <a:t>Whisper → GPT-4o</a:t>
+            </a:r>
+            <a:endParaRPr lang="en-US" sz="900" dirty="0"/>
+          </a:p>
+        </p:txBody>
+      </p:sp>
+      <p:sp>
+        <p:nvSpPr>
+          <p:cNvPr id="94" name="Shape 88"/>
+          <p:cNvSpPr/>
+          <p:nvPr/>
+        </p:nvSpPr>
+        <p:spPr>
+          <a:xfrm>
+            <a:off x="9710928" y="4087368"/>
+            <a:ext cx="1417320" cy="182880"/>
+          </a:xfrm>
+          <a:prstGeom prst="rect">
+            <a:avLst/>
+          </a:prstGeom>
+          <a:solidFill>
+            <a:srgbClr val="FFFFFF"/>
+          </a:solidFill>
+          <a:ln w="9525">
+            <a:solidFill>
+              <a:srgbClr val="E7EBF2"/>
+            </a:solidFill>
+            <a:prstDash val="solid"/>
+          </a:ln>
+        </p:spPr>
+      </p:sp>
+      <p:sp>
+        <p:nvSpPr>
+          <p:cNvPr id="95" name="Shape 89"/>
+          <p:cNvSpPr/>
+          <p:nvPr/>
+        </p:nvSpPr>
+        <p:spPr>
+          <a:xfrm>
+            <a:off x="9710928" y="4087368"/>
+            <a:ext cx="249448" cy="182880"/>
           </a:xfrm>
           <a:prstGeom prst="rect">
             <a:avLst/>
@@ -6287,23 +6597,23 @@
       </p:sp>
       <p:sp>
         <p:nvSpPr>
-          <p:cNvPr id="84" name="Text 82"/>
-          <p:cNvSpPr/>
-          <p:nvPr/>
-        </p:nvSpPr>
-        <p:spPr>
-          <a:xfrm>
-            <a:off x="9133759" y="4197096"/>
-            <a:ext cx="548640" cy="237744"/>
-          </a:xfrm>
-          <a:prstGeom prst="rect">
-            <a:avLst/>
-          </a:prstGeom>
-          <a:noFill/>
-          <a:ln/>
-        </p:spPr>
-        <p:txBody>
-          <a:bodyPr wrap="square" lIns="0" tIns="0" rIns="0" bIns="0" rtlCol="0" anchor="t"/>
+          <p:cNvPr id="96" name="Text 90"/>
+          <p:cNvSpPr/>
+          <p:nvPr/>
+        </p:nvSpPr>
+        <p:spPr>
+          <a:xfrm>
+            <a:off x="11173968" y="4059936"/>
+            <a:ext cx="457200" cy="237744"/>
+          </a:xfrm>
+          <a:prstGeom prst="rect">
+            <a:avLst/>
+          </a:prstGeom>
+          <a:noFill/>
+          <a:ln/>
+        </p:spPr>
+        <p:txBody>
+          <a:bodyPr wrap="square" lIns="0" tIns="0" rIns="0" bIns="0" rtlCol="0" anchor="ctr"/>
           <a:lstStyle/>
           <a:p>
             <a:pPr indent="0" marL="0">
@@ -6326,116 +6636,38 @@
       </p:sp>
       <p:sp>
         <p:nvSpPr>
-          <p:cNvPr id="85" name="Text 83"/>
-          <p:cNvSpPr/>
-          <p:nvPr/>
-        </p:nvSpPr>
-        <p:spPr>
-          <a:xfrm>
-            <a:off x="8668512" y="4425696"/>
-            <a:ext cx="2194560" cy="182880"/>
-          </a:xfrm>
-          <a:prstGeom prst="rect">
-            <a:avLst/>
-          </a:prstGeom>
-          <a:noFill/>
-          <a:ln/>
-        </p:spPr>
-        <p:txBody>
-          <a:bodyPr wrap="square" lIns="0" tIns="0" rIns="0" bIns="0" rtlCol="0" anchor="t"/>
-          <a:lstStyle/>
-          <a:p>
-            <a:pPr indent="0" marL="0">
-              <a:buNone/>
-            </a:pPr>
-            <a:r>
-              <a:rPr lang="en-US" sz="850" dirty="0">
-                <a:solidFill>
-                  <a:srgbClr val="4F5B73"/>
+          <p:cNvPr id="97" name="Text 91"/>
+          <p:cNvSpPr/>
+          <p:nvPr/>
+        </p:nvSpPr>
+        <p:spPr>
+          <a:xfrm>
+            <a:off x="8668512" y="4498848"/>
+            <a:ext cx="2880360" cy="502920"/>
+          </a:xfrm>
+          <a:prstGeom prst="rect">
+            <a:avLst/>
+          </a:prstGeom>
+          <a:noFill/>
+          <a:ln/>
+        </p:spPr>
+        <p:txBody>
+          <a:bodyPr wrap="square" lIns="0" tIns="0" rIns="0" bIns="0" rtlCol="0" anchor="t"/>
+          <a:lstStyle/>
+          <a:p>
+            <a:pPr indent="0" marL="0">
+              <a:buNone/>
+            </a:pPr>
+            <a:r>
+              <a:rPr lang="en-US" sz="750" dirty="0">
+                <a:solidFill>
+                  <a:srgbClr val="8791A5"/>
                 </a:solidFill>
                 <a:latin typeface="Segoe UI" pitchFamily="34" charset="0"/>
                 <a:ea typeface="Segoe UI" pitchFamily="34" charset="-122"/>
                 <a:cs typeface="Segoe UI" pitchFamily="34" charset="-120"/>
               </a:rPr>
-              <a:t>Whisper → GPT-4o</a:t>
-            </a:r>
-            <a:endParaRPr lang="en-US" sz="850" dirty="0"/>
-          </a:p>
-        </p:txBody>
-      </p:sp>
-      <p:sp>
-        <p:nvSpPr>
-          <p:cNvPr id="86" name="Text 84"/>
-          <p:cNvSpPr/>
-          <p:nvPr/>
-        </p:nvSpPr>
-        <p:spPr>
-          <a:xfrm>
-            <a:off x="10775290" y="2825496"/>
-            <a:ext cx="548640" cy="237744"/>
-          </a:xfrm>
-          <a:prstGeom prst="rect">
-            <a:avLst/>
-          </a:prstGeom>
-          <a:noFill/>
-          <a:ln/>
-        </p:spPr>
-        <p:txBody>
-          <a:bodyPr wrap="square" lIns="0" tIns="0" rIns="0" bIns="0" rtlCol="0" anchor="t"/>
-          <a:lstStyle/>
-          <a:p>
-            <a:pPr indent="0" marL="0">
-              <a:buNone/>
-            </a:pPr>
-            <a:r>
-              <a:rPr lang="en-US" sz="950" dirty="0">
-                <a:solidFill>
-                  <a:srgbClr val="1428A0"/>
-                </a:solidFill>
-                <a:latin typeface="Segoe UI Semibold" pitchFamily="34" charset="0"/>
-                <a:ea typeface="Segoe UI Semibold" pitchFamily="34" charset="-122"/>
-                <a:cs typeface="Segoe UI Semibold" pitchFamily="34" charset="-120"/>
-              </a:rPr>
-              <a:t>0.88</a:t>
-            </a:r>
-            <a:endParaRPr lang="en-US" sz="950" dirty="0"/>
-          </a:p>
-        </p:txBody>
-      </p:sp>
-      <p:sp>
-        <p:nvSpPr>
-          <p:cNvPr id="87" name="Text 85"/>
-          <p:cNvSpPr/>
-          <p:nvPr/>
-        </p:nvSpPr>
-        <p:spPr>
-          <a:xfrm>
-            <a:off x="8668512" y="4645152"/>
-            <a:ext cx="2880360" cy="384048"/>
-          </a:xfrm>
-          <a:prstGeom prst="rect">
-            <a:avLst/>
-          </a:prstGeom>
-          <a:noFill/>
-          <a:ln/>
-        </p:spPr>
-        <p:txBody>
-          <a:bodyPr wrap="square" lIns="0" tIns="0" rIns="0" bIns="0" rtlCol="0" anchor="t"/>
-          <a:lstStyle/>
-          <a:p>
-            <a:pPr indent="0" marL="0">
-              <a:buNone/>
-            </a:pPr>
-            <a:r>
-              <a:rPr lang="en-US" sz="750" dirty="0">
-                <a:solidFill>
-                  <a:srgbClr val="8791A5"/>
-                </a:solidFill>
-                <a:latin typeface="Segoe UI" pitchFamily="34" charset="0"/>
-                <a:ea typeface="Segoe UI" pitchFamily="34" charset="-122"/>
-                <a:cs typeface="Segoe UI" pitchFamily="34" charset="-120"/>
-              </a:rPr>
-              <a:t>Baselines: FDB-v3 paper, which names the cause: “models commit intermediate parameters before the correction arrives.”</a:t>
+              <a:t>Strict Pass@1 on the benchmark's self-correction items. Baselines: the FDB-v3 paper, which names the cause: “models commit intermediate parameters before the correction arrives.”</a:t>
             </a:r>
             <a:endParaRPr lang="en-US" sz="750" dirty="0"/>
           </a:p>
@@ -6443,7 +6675,7 @@
       </p:sp>
       <p:sp>
         <p:nvSpPr>
-          <p:cNvPr id="88" name="Shape 86"/>
+          <p:cNvPr id="98" name="Shape 92"/>
           <p:cNvSpPr/>
           <p:nvPr/>
         </p:nvSpPr>
@@ -6470,7 +6702,7 @@
       </p:sp>
       <p:sp>
         <p:nvSpPr>
-          <p:cNvPr id="89" name="Shape 87"/>
+          <p:cNvPr id="99" name="Shape 93"/>
           <p:cNvSpPr/>
           <p:nvPr/>
         </p:nvSpPr>
@@ -6495,7 +6727,7 @@
       </p:sp>
       <p:sp>
         <p:nvSpPr>
-          <p:cNvPr id="90" name="Text 88"/>
+          <p:cNvPr id="100" name="Text 94"/>
           <p:cNvSpPr/>
           <p:nvPr/>
         </p:nvSpPr>
@@ -6534,7 +6766,7 @@
       </p:sp>
       <p:sp>
         <p:nvSpPr>
-          <p:cNvPr id="91" name="Text 89"/>
+          <p:cNvPr id="101" name="Text 95"/>
           <p:cNvSpPr/>
           <p:nvPr/>
         </p:nvSpPr>
@@ -6576,7 +6808,7 @@
       </p:sp>
       <p:sp>
         <p:nvSpPr>
-          <p:cNvPr id="92" name="Shape 90"/>
+          <p:cNvPr id="102" name="Shape 96"/>
           <p:cNvSpPr/>
           <p:nvPr/>
         </p:nvSpPr>
@@ -6603,7 +6835,7 @@
       </p:sp>
       <p:sp>
         <p:nvSpPr>
-          <p:cNvPr id="93" name="Shape 91"/>
+          <p:cNvPr id="103" name="Shape 97"/>
           <p:cNvSpPr/>
           <p:nvPr/>
         </p:nvSpPr>
@@ -6628,7 +6860,7 @@
       </p:sp>
       <p:sp>
         <p:nvSpPr>
-          <p:cNvPr id="94" name="Text 92"/>
+          <p:cNvPr id="104" name="Text 98"/>
           <p:cNvSpPr/>
           <p:nvPr/>
         </p:nvSpPr>
@@ -6667,7 +6899,7 @@
       </p:sp>
       <p:sp>
         <p:nvSpPr>
-          <p:cNvPr id="95" name="Text 93"/>
+          <p:cNvPr id="105" name="Text 99"/>
           <p:cNvSpPr/>
           <p:nvPr/>
         </p:nvSpPr>
@@ -6709,7 +6941,7 @@
       </p:sp>
       <p:sp>
         <p:nvSpPr>
-          <p:cNvPr id="96" name="Shape 94"/>
+          <p:cNvPr id="106" name="Shape 100"/>
           <p:cNvSpPr/>
           <p:nvPr/>
         </p:nvSpPr>
@@ -6736,7 +6968,7 @@
       </p:sp>
       <p:sp>
         <p:nvSpPr>
-          <p:cNvPr id="97" name="Shape 95"/>
+          <p:cNvPr id="107" name="Shape 101"/>
           <p:cNvSpPr/>
           <p:nvPr/>
         </p:nvSpPr>
@@ -6761,7 +6993,7 @@
       </p:sp>
       <p:sp>
         <p:nvSpPr>
-          <p:cNvPr id="98" name="Text 96"/>
+          <p:cNvPr id="108" name="Text 102"/>
           <p:cNvSpPr/>
           <p:nvPr/>
         </p:nvSpPr>
@@ -6800,7 +7032,7 @@
       </p:sp>
       <p:sp>
         <p:nvSpPr>
-          <p:cNvPr id="99" name="Text 97"/>
+          <p:cNvPr id="109" name="Text 103"/>
           <p:cNvSpPr/>
           <p:nvPr/>
         </p:nvSpPr>
@@ -19790,7 +20022,7 @@
                 <a:ea typeface="Segoe UI Semibold" pitchFamily="34" charset="-122"/>
                 <a:cs typeface="Segoe UI Semibold" pitchFamily="34" charset="-120"/>
               </a:rPr>
-              <a:t>LIMITATIONS AND WHAT'S NEXT</a:t>
+              <a:t>IMPACT AND WHAT'S NEXT</a:t>
             </a:r>
             <a:endParaRPr lang="en-US" sz="1000" dirty="0"/>
           </a:p>
@@ -19868,7 +20100,7 @@
                 <a:ea typeface="Segoe UI Semibold" pitchFamily="34" charset="-122"/>
                 <a:cs typeface="Segoe UI Semibold" pitchFamily="34" charset="-120"/>
               </a:rPr>
-              <a:t>What we still lose, and where DUET goes next</a:t>
+              <a:t>One coordinator for every surface where a voice can act</a:t>
             </a:r>
             <a:endParaRPr lang="en-US" sz="2700" dirty="0"/>
           </a:p>
@@ -19907,7 +20139,7 @@
                 <a:ea typeface="Segoe UI" pitchFamily="34" charset="-122"/>
                 <a:cs typeface="Segoe UI" pitchFamily="34" charset="-120"/>
               </a:rPr>
-              <a:t>Every limitation below is measured in the reported run; every next step is a PRISM worklet.</a:t>
+              <a:t>Wherever a spoken request can change something real, a correction has to win and nothing may happen twice.</a:t>
             </a:r>
             <a:endParaRPr lang="en-US" sz="1400" dirty="0"/>
           </a:p>
@@ -20022,12 +20254,12 @@
         </p:nvSpPr>
         <p:spPr>
           <a:xfrm>
-            <a:off x="502920" y="1627632"/>
-            <a:ext cx="5440680" cy="4087368"/>
+            <a:off x="502920" y="1600200"/>
+            <a:ext cx="6967728" cy="4114800"/>
           </a:xfrm>
           <a:prstGeom prst="roundRect">
             <a:avLst>
-              <a:gd name="adj" fmla="val 2237"/>
+              <a:gd name="adj" fmla="val 2222"/>
             </a:avLst>
           </a:prstGeom>
           <a:solidFill>
@@ -20049,295 +20281,783 @@
         </p:nvSpPr>
         <p:spPr>
           <a:xfrm>
-            <a:off x="685800" y="1755648"/>
-            <a:ext cx="4572000" cy="228600"/>
-          </a:xfrm>
-          <a:prstGeom prst="rect">
-            <a:avLst/>
-          </a:prstGeom>
-          <a:noFill/>
-          <a:ln/>
-        </p:spPr>
-        <p:txBody>
-          <a:bodyPr wrap="square" lIns="0" tIns="0" rIns="0" bIns="0" rtlCol="0" anchor="t"/>
-          <a:lstStyle/>
-          <a:p>
-            <a:pPr indent="0" marL="0">
-              <a:buNone/>
-            </a:pPr>
-            <a:r>
-              <a:rPr lang="en-US" sz="1000" spc="150" kern="0" dirty="0">
-                <a:solidFill>
-                  <a:srgbClr val="C73A3A"/>
+            <a:off x="685800" y="1737360"/>
+            <a:ext cx="5486400" cy="219456"/>
+          </a:xfrm>
+          <a:prstGeom prst="rect">
+            <a:avLst/>
+          </a:prstGeom>
+          <a:noFill/>
+          <a:ln/>
+        </p:spPr>
+        <p:txBody>
+          <a:bodyPr wrap="square" lIns="0" tIns="0" rIns="0" bIns="0" rtlCol="0" anchor="t"/>
+          <a:lstStyle/>
+          <a:p>
+            <a:pPr indent="0" marL="0">
+              <a:buNone/>
+            </a:pPr>
+            <a:r>
+              <a:rPr lang="en-US" sz="950" spc="200" kern="0" dirty="0">
+                <a:solidFill>
+                  <a:srgbClr val="4F5B73"/>
                 </a:solidFill>
                 <a:latin typeface="Segoe UI Semibold" pitchFamily="34" charset="0"/>
                 <a:ea typeface="Segoe UI Semibold" pitchFamily="34" charset="-122"/>
                 <a:cs typeface="Segoe UI Semibold" pitchFamily="34" charset="-120"/>
               </a:rPr>
-              <a:t>LIMITATIONS WE MEASURED</a:t>
-            </a:r>
-            <a:endParaRPr lang="en-US" sz="1000" dirty="0"/>
-          </a:p>
-        </p:txBody>
-      </p:sp>
-      <p:sp>
-        <p:nvSpPr>
-          <p:cNvPr id="12" name="Text 10"/>
-          <p:cNvSpPr/>
-          <p:nvPr/>
-        </p:nvSpPr>
-        <p:spPr>
-          <a:xfrm>
-            <a:off x="685800" y="2103120"/>
-            <a:ext cx="5120640" cy="3566160"/>
-          </a:xfrm>
-          <a:prstGeom prst="rect">
-            <a:avLst/>
-          </a:prstGeom>
-          <a:noFill/>
-          <a:ln/>
-        </p:spPr>
-        <p:txBody>
-          <a:bodyPr wrap="square" lIns="0" tIns="0" rIns="0" bIns="0" rtlCol="0" anchor="t"/>
-          <a:lstStyle/>
-          <a:p>
-            <a:pPr indent="0" marL="0">
-              <a:spcAft>
-                <a:spcPts val="1300"/>
-              </a:spcAft>
-              <a:buNone/>
-            </a:pPr>
-            <a:r>
-              <a:rPr lang="en-US" sz="1150" b="1" dirty="0">
-                <a:solidFill>
-                  <a:srgbClr val="0F1C3F"/>
+              <a:t>WHERE THE SAME GUARANTEE MATTERS</a:t>
+            </a:r>
+            <a:endParaRPr lang="en-US" sz="950" dirty="0"/>
+          </a:p>
+        </p:txBody>
+      </p:sp>
+      <p:sp>
+        <p:nvSpPr>
+          <p:cNvPr id="12" name="Shape 10"/>
+          <p:cNvSpPr/>
+          <p:nvPr/>
+        </p:nvSpPr>
+        <p:spPr>
+          <a:xfrm>
+            <a:off x="685800" y="2057400"/>
+            <a:ext cx="3218688" cy="1645920"/>
+          </a:xfrm>
+          <a:prstGeom prst="roundRect">
+            <a:avLst>
+              <a:gd name="adj" fmla="val 4444"/>
+            </a:avLst>
+          </a:prstGeom>
+          <a:solidFill>
+            <a:srgbClr val="FFFFFF"/>
+          </a:solidFill>
+          <a:ln w="12700">
+            <a:solidFill>
+              <a:srgbClr val="D9DFEA"/>
+            </a:solidFill>
+            <a:prstDash val="solid"/>
+          </a:ln>
+        </p:spPr>
+      </p:sp>
+      <p:sp>
+        <p:nvSpPr>
+          <p:cNvPr id="13" name="Shape 11"/>
+          <p:cNvSpPr/>
+          <p:nvPr/>
+        </p:nvSpPr>
+        <p:spPr>
+          <a:xfrm>
+            <a:off x="685800" y="2185416"/>
+            <a:ext cx="54864" cy="1389888"/>
+          </a:xfrm>
+          <a:prstGeom prst="rect">
+            <a:avLst/>
+          </a:prstGeom>
+          <a:solidFill>
+            <a:srgbClr val="1428A0"/>
+          </a:solidFill>
+          <a:ln w="12700">
+            <a:solidFill>
+              <a:srgbClr val="1428A0"/>
+            </a:solidFill>
+            <a:prstDash val="solid"/>
+          </a:ln>
+        </p:spPr>
+      </p:sp>
+      <p:sp>
+        <p:nvSpPr>
+          <p:cNvPr id="14" name="Text 12"/>
+          <p:cNvSpPr/>
+          <p:nvPr/>
+        </p:nvSpPr>
+        <p:spPr>
+          <a:xfrm>
+            <a:off x="886968" y="2185416"/>
+            <a:ext cx="2926080" cy="256032"/>
+          </a:xfrm>
+          <a:prstGeom prst="rect">
+            <a:avLst/>
+          </a:prstGeom>
+          <a:noFill/>
+          <a:ln/>
+        </p:spPr>
+        <p:txBody>
+          <a:bodyPr wrap="square" lIns="0" tIns="0" rIns="0" bIns="0" rtlCol="0" anchor="t"/>
+          <a:lstStyle/>
+          <a:p>
+            <a:pPr indent="0" marL="0">
+              <a:buNone/>
+            </a:pPr>
+            <a:r>
+              <a:rPr lang="en-US" sz="1200" dirty="0">
+                <a:solidFill>
+                  <a:srgbClr val="1428A0"/>
                 </a:solidFill>
                 <a:latin typeface="Segoe UI Semibold" pitchFamily="34" charset="0"/>
                 <a:ea typeface="Segoe UI Semibold" pitchFamily="34" charset="-122"/>
                 <a:cs typeface="Segoe UI Semibold" pitchFamily="34" charset="-120"/>
               </a:rPr>
-              <a:t>Latency. </a:t>
-            </a:r>
-            <a:pPr indent="0" marL="0">
-              <a:spcAft>
-                <a:spcPts val="1300"/>
-              </a:spcAft>
-              <a:buNone/>
-            </a:pPr>
-            <a:r>
-              <a:rPr lang="en-US" sz="1150" dirty="0">
-                <a:solidFill>
-                  <a:srgbClr val="4F5B73"/>
+              <a:t>SmartThings home</a:t>
+            </a:r>
+            <a:endParaRPr lang="en-US" sz="1200" dirty="0"/>
+          </a:p>
+        </p:txBody>
+      </p:sp>
+      <p:sp>
+        <p:nvSpPr>
+          <p:cNvPr id="15" name="Text 13"/>
+          <p:cNvSpPr/>
+          <p:nvPr/>
+        </p:nvSpPr>
+        <p:spPr>
+          <a:xfrm>
+            <a:off x="886968" y="2514600"/>
+            <a:ext cx="2907792" cy="502920"/>
+          </a:xfrm>
+          <a:prstGeom prst="rect">
+            <a:avLst/>
+          </a:prstGeom>
+          <a:noFill/>
+          <a:ln/>
+        </p:spPr>
+        <p:txBody>
+          <a:bodyPr wrap="square" lIns="0" tIns="0" rIns="0" bIns="0" rtlCol="0" anchor="t"/>
+          <a:lstStyle/>
+          <a:p>
+            <a:pPr indent="0" marL="0">
+              <a:buNone/>
+            </a:pPr>
+            <a:r>
+              <a:rPr lang="en-US" sz="1050" i="1" dirty="0">
+                <a:solidFill>
+                  <a:srgbClr val="0F1C3F"/>
                 </a:solidFill>
                 <a:latin typeface="Segoe UI" pitchFamily="34" charset="0"/>
                 <a:ea typeface="Segoe UI" pitchFamily="34" charset="-122"/>
                 <a:cs typeface="Segoe UI" pitchFamily="34" charset="-120"/>
               </a:rPr>
-              <a:t>First response 4.8 s; key information 14.4 s (GPT-Realtime: 6.9 s). A hosted model call takes 3.3 s at the median, 7.2 s at p90.</a:t>
-            </a:r>
-            <a:endParaRPr lang="en-US" sz="1150" dirty="0"/>
-          </a:p>
-          <a:p>
-            <a:pPr indent="0" marL="0">
-              <a:spcAft>
-                <a:spcPts val="1300"/>
-              </a:spcAft>
-              <a:buNone/>
-            </a:pPr>
-            <a:r>
-              <a:rPr lang="en-US" sz="1150" b="1" dirty="0">
-                <a:solidFill>
-                  <a:srgbClr val="0F1C3F"/>
+              <a:t>“Lock the front door… actually, not yet.”</a:t>
+            </a:r>
+            <a:endParaRPr lang="en-US" sz="1050" dirty="0"/>
+          </a:p>
+        </p:txBody>
+      </p:sp>
+      <p:sp>
+        <p:nvSpPr>
+          <p:cNvPr id="16" name="Text 14"/>
+          <p:cNvSpPr/>
+          <p:nvPr/>
+        </p:nvSpPr>
+        <p:spPr>
+          <a:xfrm>
+            <a:off x="886968" y="3063240"/>
+            <a:ext cx="2907792" cy="502920"/>
+          </a:xfrm>
+          <a:prstGeom prst="rect">
+            <a:avLst/>
+          </a:prstGeom>
+          <a:noFill/>
+          <a:ln/>
+        </p:spPr>
+        <p:txBody>
+          <a:bodyPr wrap="square" lIns="0" tIns="0" rIns="0" bIns="0" rtlCol="0" anchor="t"/>
+          <a:lstStyle/>
+          <a:p>
+            <a:pPr indent="0" marL="0">
+              <a:buNone/>
+            </a:pPr>
+            <a:r>
+              <a:rPr lang="en-US" sz="1050" b="1" dirty="0">
+                <a:solidFill>
+                  <a:srgbClr val="13804F"/>
                 </a:solidFill>
                 <a:latin typeface="Segoe UI Semibold" pitchFamily="34" charset="0"/>
                 <a:ea typeface="Segoe UI Semibold" pitchFamily="34" charset="-122"/>
                 <a:cs typeface="Segoe UI Semibold" pitchFamily="34" charset="-120"/>
               </a:rPr>
-              <a:t>Provider stalls. </a:t>
-            </a:r>
-            <a:pPr indent="0" marL="0">
-              <a:spcAft>
-                <a:spcPts val="1300"/>
-              </a:spcAft>
-              <a:buNone/>
-            </a:pPr>
-            <a:r>
-              <a:rPr lang="en-US" sz="1150" dirty="0">
-                <a:solidFill>
-                  <a:srgbClr val="4F5B73"/>
+              <a:t>DUET  </a:t>
+            </a:r>
+            <a:pPr indent="0" marL="0">
+              <a:buNone/>
+            </a:pPr>
+            <a:r>
+              <a:rPr lang="en-US" sz="1050" dirty="0">
+                <a:solidFill>
+                  <a:srgbClr val="0F1C3F"/>
                 </a:solidFill>
                 <a:latin typeface="Segoe UI" pitchFamily="34" charset="0"/>
                 <a:ea typeface="Segoe UI" pitchFamily="34" charset="-122"/>
                 <a:cs typeface="Segoe UI" pitchFamily="34" charset="-120"/>
               </a:rPr>
-              <a:t>3 of 100 recordings were lost to model calls Google never answered (504), despite backups on every key.</a:t>
-            </a:r>
-            <a:endParaRPr lang="en-US" sz="1150" dirty="0"/>
-          </a:p>
-          <a:p>
-            <a:pPr indent="0" marL="0">
-              <a:spcAft>
-                <a:spcPts val="1300"/>
-              </a:spcAft>
-              <a:buNone/>
-            </a:pPr>
-            <a:r>
-              <a:rPr lang="en-US" sz="1150" b="1" dirty="0">
-                <a:solidFill>
-                  <a:srgbClr val="0F1C3F"/>
+              <a:t>The lock never acts on a plan the user took back.</a:t>
+            </a:r>
+            <a:endParaRPr lang="en-US" sz="1050" dirty="0"/>
+          </a:p>
+        </p:txBody>
+      </p:sp>
+      <p:sp>
+        <p:nvSpPr>
+          <p:cNvPr id="17" name="Shape 15"/>
+          <p:cNvSpPr/>
+          <p:nvPr/>
+        </p:nvSpPr>
+        <p:spPr>
+          <a:xfrm>
+            <a:off x="4050792" y="2057400"/>
+            <a:ext cx="3218688" cy="1645920"/>
+          </a:xfrm>
+          <a:prstGeom prst="roundRect">
+            <a:avLst>
+              <a:gd name="adj" fmla="val 4444"/>
+            </a:avLst>
+          </a:prstGeom>
+          <a:solidFill>
+            <a:srgbClr val="FFFFFF"/>
+          </a:solidFill>
+          <a:ln w="12700">
+            <a:solidFill>
+              <a:srgbClr val="D9DFEA"/>
+            </a:solidFill>
+            <a:prstDash val="solid"/>
+          </a:ln>
+        </p:spPr>
+      </p:sp>
+      <p:sp>
+        <p:nvSpPr>
+          <p:cNvPr id="18" name="Shape 16"/>
+          <p:cNvSpPr/>
+          <p:nvPr/>
+        </p:nvSpPr>
+        <p:spPr>
+          <a:xfrm>
+            <a:off x="4050792" y="2185416"/>
+            <a:ext cx="54864" cy="1389888"/>
+          </a:xfrm>
+          <a:prstGeom prst="rect">
+            <a:avLst/>
+          </a:prstGeom>
+          <a:solidFill>
+            <a:srgbClr val="5B3FC4"/>
+          </a:solidFill>
+          <a:ln w="12700">
+            <a:solidFill>
+              <a:srgbClr val="5B3FC4"/>
+            </a:solidFill>
+            <a:prstDash val="solid"/>
+          </a:ln>
+        </p:spPr>
+      </p:sp>
+      <p:sp>
+        <p:nvSpPr>
+          <p:cNvPr id="19" name="Text 17"/>
+          <p:cNvSpPr/>
+          <p:nvPr/>
+        </p:nvSpPr>
+        <p:spPr>
+          <a:xfrm>
+            <a:off x="4251960" y="2185416"/>
+            <a:ext cx="2926080" cy="256032"/>
+          </a:xfrm>
+          <a:prstGeom prst="rect">
+            <a:avLst/>
+          </a:prstGeom>
+          <a:noFill/>
+          <a:ln/>
+        </p:spPr>
+        <p:txBody>
+          <a:bodyPr wrap="square" lIns="0" tIns="0" rIns="0" bIns="0" rtlCol="0" anchor="t"/>
+          <a:lstStyle/>
+          <a:p>
+            <a:pPr indent="0" marL="0">
+              <a:buNone/>
+            </a:pPr>
+            <a:r>
+              <a:rPr lang="en-US" sz="1200" dirty="0">
+                <a:solidFill>
+                  <a:srgbClr val="5B3FC4"/>
                 </a:solidFill>
                 <a:latin typeface="Segoe UI Semibold" pitchFamily="34" charset="0"/>
                 <a:ea typeface="Segoe UI Semibold" pitchFamily="34" charset="-122"/>
                 <a:cs typeface="Segoe UI Semibold" pitchFamily="34" charset="-120"/>
               </a:rPr>
-              <a:t>Hearing. </a:t>
-            </a:r>
-            <a:pPr indent="0" marL="0">
-              <a:spcAft>
-                <a:spcPts val="1300"/>
-              </a:spcAft>
-              <a:buNone/>
-            </a:pPr>
-            <a:r>
-              <a:rPr lang="en-US" sz="1150" dirty="0">
-                <a:solidFill>
-                  <a:srgbClr val="4F5B73"/>
+              <a:t>Samsung service line</a:t>
+            </a:r>
+            <a:endParaRPr lang="en-US" sz="1200" dirty="0"/>
+          </a:p>
+        </p:txBody>
+      </p:sp>
+      <p:sp>
+        <p:nvSpPr>
+          <p:cNvPr id="20" name="Text 18"/>
+          <p:cNvSpPr/>
+          <p:nvPr/>
+        </p:nvSpPr>
+        <p:spPr>
+          <a:xfrm>
+            <a:off x="4251960" y="2514600"/>
+            <a:ext cx="2907792" cy="502920"/>
+          </a:xfrm>
+          <a:prstGeom prst="rect">
+            <a:avLst/>
+          </a:prstGeom>
+          <a:noFill/>
+          <a:ln/>
+        </p:spPr>
+        <p:txBody>
+          <a:bodyPr wrap="square" lIns="0" tIns="0" rIns="0" bIns="0" rtlCol="0" anchor="t"/>
+          <a:lstStyle/>
+          <a:p>
+            <a:pPr indent="0" marL="0">
+              <a:buNone/>
+            </a:pPr>
+            <a:r>
+              <a:rPr lang="en-US" sz="1050" i="1" dirty="0">
+                <a:solidFill>
+                  <a:srgbClr val="0F1C3F"/>
                 </a:solidFill>
                 <a:latin typeface="Segoe UI" pitchFamily="34" charset="0"/>
                 <a:ea typeface="Segoe UI" pitchFamily="34" charset="-122"/>
                 <a:cs typeface="Segoe UI" pitchFamily="34" charset="-120"/>
               </a:rPr>
-              <a:t>Spelled-out codes are misheard (“D, E, L, bye, V” for DELIV): 7 of 100 items.</a:t>
-            </a:r>
-            <a:endParaRPr lang="en-US" sz="1150" dirty="0"/>
-          </a:p>
-          <a:p>
-            <a:pPr indent="0" marL="0">
-              <a:spcAft>
-                <a:spcPts val="1300"/>
-              </a:spcAft>
-              <a:buNone/>
-            </a:pPr>
-            <a:r>
-              <a:rPr lang="en-US" sz="1150" b="1" dirty="0">
-                <a:solidFill>
-                  <a:srgbClr val="0F1C3F"/>
+              <a:t>“Book a technician for the washer… no, the dryer.”</a:t>
+            </a:r>
+            <a:endParaRPr lang="en-US" sz="1050" dirty="0"/>
+          </a:p>
+        </p:txBody>
+      </p:sp>
+      <p:sp>
+        <p:nvSpPr>
+          <p:cNvPr id="21" name="Text 19"/>
+          <p:cNvSpPr/>
+          <p:nvPr/>
+        </p:nvSpPr>
+        <p:spPr>
+          <a:xfrm>
+            <a:off x="4251960" y="3063240"/>
+            <a:ext cx="2907792" cy="502920"/>
+          </a:xfrm>
+          <a:prstGeom prst="rect">
+            <a:avLst/>
+          </a:prstGeom>
+          <a:noFill/>
+          <a:ln/>
+        </p:spPr>
+        <p:txBody>
+          <a:bodyPr wrap="square" lIns="0" tIns="0" rIns="0" bIns="0" rtlCol="0" anchor="t"/>
+          <a:lstStyle/>
+          <a:p>
+            <a:pPr indent="0" marL="0">
+              <a:buNone/>
+            </a:pPr>
+            <a:r>
+              <a:rPr lang="en-US" sz="1050" b="1" dirty="0">
+                <a:solidFill>
+                  <a:srgbClr val="13804F"/>
                 </a:solidFill>
                 <a:latin typeface="Segoe UI Semibold" pitchFamily="34" charset="0"/>
                 <a:ea typeface="Segoe UI Semibold" pitchFamily="34" charset="-122"/>
                 <a:cs typeface="Segoe UI Semibold" pitchFamily="34" charset="-120"/>
               </a:rPr>
-              <a:t>Response quality 0.73 </a:t>
-            </a:r>
-            <a:pPr indent="0" marL="0">
-              <a:spcAft>
-                <a:spcPts val="1300"/>
-              </a:spcAft>
-              <a:buNone/>
-            </a:pPr>
-            <a:r>
-              <a:rPr lang="en-US" sz="1150" dirty="0">
-                <a:solidFill>
-                  <a:srgbClr val="4F5B73"/>
+              <a:t>DUET  </a:t>
+            </a:r>
+            <a:pPr indent="0" marL="0">
+              <a:buNone/>
+            </a:pPr>
+            <a:r>
+              <a:rPr lang="en-US" sz="1050" dirty="0">
+                <a:solidFill>
+                  <a:srgbClr val="0F1C3F"/>
                 </a:solidFill>
                 <a:latin typeface="Segoe UI" pitchFamily="34" charset="0"/>
                 <a:ea typeface="Segoe UI" pitchFamily="34" charset="-122"/>
                 <a:cs typeface="Segoe UI" pitchFamily="34" charset="-120"/>
               </a:rPr>
-              <a:t>(GPT-Realtime 0.79): the answers are correct but plain.</a:t>
-            </a:r>
-            <a:endParaRPr lang="en-US" sz="1150" dirty="0"/>
-          </a:p>
-          <a:p>
-            <a:pPr indent="0" marL="0">
-              <a:spcAft>
-                <a:spcPts val="1300"/>
-              </a:spcAft>
-              <a:buNone/>
-            </a:pPr>
-            <a:r>
-              <a:rPr lang="en-US" sz="1150" b="1" dirty="0">
-                <a:solidFill>
-                  <a:srgbClr val="0F1C3F"/>
+              <a:t>One visit is booked, for the dryer.</a:t>
+            </a:r>
+            <a:endParaRPr lang="en-US" sz="1050" dirty="0"/>
+          </a:p>
+        </p:txBody>
+      </p:sp>
+      <p:sp>
+        <p:nvSpPr>
+          <p:cNvPr id="22" name="Shape 20"/>
+          <p:cNvSpPr/>
+          <p:nvPr/>
+        </p:nvSpPr>
+        <p:spPr>
+          <a:xfrm>
+            <a:off x="685800" y="3840480"/>
+            <a:ext cx="3218688" cy="1645920"/>
+          </a:xfrm>
+          <a:prstGeom prst="roundRect">
+            <a:avLst>
+              <a:gd name="adj" fmla="val 4444"/>
+            </a:avLst>
+          </a:prstGeom>
+          <a:solidFill>
+            <a:srgbClr val="FFFFFF"/>
+          </a:solidFill>
+          <a:ln w="12700">
+            <a:solidFill>
+              <a:srgbClr val="D9DFEA"/>
+            </a:solidFill>
+            <a:prstDash val="solid"/>
+          </a:ln>
+        </p:spPr>
+      </p:sp>
+      <p:sp>
+        <p:nvSpPr>
+          <p:cNvPr id="23" name="Shape 21"/>
+          <p:cNvSpPr/>
+          <p:nvPr/>
+        </p:nvSpPr>
+        <p:spPr>
+          <a:xfrm>
+            <a:off x="685800" y="3968496"/>
+            <a:ext cx="54864" cy="1389888"/>
+          </a:xfrm>
+          <a:prstGeom prst="rect">
+            <a:avLst/>
+          </a:prstGeom>
+          <a:solidFill>
+            <a:srgbClr val="B8680A"/>
+          </a:solidFill>
+          <a:ln w="12700">
+            <a:solidFill>
+              <a:srgbClr val="B8680A"/>
+            </a:solidFill>
+            <a:prstDash val="solid"/>
+          </a:ln>
+        </p:spPr>
+      </p:sp>
+      <p:sp>
+        <p:nvSpPr>
+          <p:cNvPr id="24" name="Text 22"/>
+          <p:cNvSpPr/>
+          <p:nvPr/>
+        </p:nvSpPr>
+        <p:spPr>
+          <a:xfrm>
+            <a:off x="886968" y="3968496"/>
+            <a:ext cx="2926080" cy="256032"/>
+          </a:xfrm>
+          <a:prstGeom prst="rect">
+            <a:avLst/>
+          </a:prstGeom>
+          <a:noFill/>
+          <a:ln/>
+        </p:spPr>
+        <p:txBody>
+          <a:bodyPr wrap="square" lIns="0" tIns="0" rIns="0" bIns="0" rtlCol="0" anchor="t"/>
+          <a:lstStyle/>
+          <a:p>
+            <a:pPr indent="0" marL="0">
+              <a:buNone/>
+            </a:pPr>
+            <a:r>
+              <a:rPr lang="en-US" sz="1200" dirty="0">
+                <a:solidFill>
+                  <a:srgbClr val="B8680A"/>
                 </a:solidFill>
                 <a:latin typeface="Segoe UI Semibold" pitchFamily="34" charset="0"/>
                 <a:ea typeface="Segoe UI Semibold" pitchFamily="34" charset="-122"/>
                 <a:cs typeface="Segoe UI Semibold" pitchFamily="34" charset="-120"/>
               </a:rPr>
-              <a:t>Our scoring. </a:t>
-            </a:r>
-            <a:pPr indent="0" marL="0">
-              <a:spcAft>
-                <a:spcPts val="1300"/>
-              </a:spcAft>
-              <a:buNone/>
-            </a:pPr>
-            <a:r>
-              <a:rPr lang="en-US" sz="1150" dirty="0">
-                <a:solidFill>
-                  <a:srgbClr val="4F5B73"/>
+              <a:t>Android Auto and Car-to-Home</a:t>
+            </a:r>
+            <a:endParaRPr lang="en-US" sz="1200" dirty="0"/>
+          </a:p>
+        </p:txBody>
+      </p:sp>
+      <p:sp>
+        <p:nvSpPr>
+          <p:cNvPr id="25" name="Text 23"/>
+          <p:cNvSpPr/>
+          <p:nvPr/>
+        </p:nvSpPr>
+        <p:spPr>
+          <a:xfrm>
+            <a:off x="886968" y="4297680"/>
+            <a:ext cx="2907792" cy="502920"/>
+          </a:xfrm>
+          <a:prstGeom prst="rect">
+            <a:avLst/>
+          </a:prstGeom>
+          <a:noFill/>
+          <a:ln/>
+        </p:spPr>
+        <p:txBody>
+          <a:bodyPr wrap="square" lIns="0" tIns="0" rIns="0" bIns="0" rtlCol="0" anchor="t"/>
+          <a:lstStyle/>
+          <a:p>
+            <a:pPr indent="0" marL="0">
+              <a:buNone/>
+            </a:pPr>
+            <a:r>
+              <a:rPr lang="en-US" sz="1050" i="1" dirty="0">
+                <a:solidFill>
+                  <a:srgbClr val="0F1C3F"/>
                 </a:solidFill>
                 <a:latin typeface="Segoe UI" pitchFamily="34" charset="0"/>
                 <a:ea typeface="Segoe UI" pitchFamily="34" charset="-122"/>
                 <a:cs typeface="Segoe UI" pitchFamily="34" charset="-120"/>
               </a:rPr>
-              <a:t>A Gemma stand-in for the gpt-4o judge; 75 of 100 by exact match with no judge at all.</a:t>
-            </a:r>
-            <a:endParaRPr lang="en-US" sz="1150" dirty="0"/>
-          </a:p>
-          <a:p>
-            <a:pPr indent="0" marL="0">
-              <a:spcAft>
-                <a:spcPts val="1300"/>
-              </a:spcAft>
-              <a:buNone/>
-            </a:pPr>
-            <a:r>
-              <a:rPr lang="en-US" sz="1150" b="1" dirty="0">
-                <a:solidFill>
-                  <a:srgbClr val="0F1C3F"/>
+              <a:t>“The Starbucks on 5th… no, the one by the office.”</a:t>
+            </a:r>
+            <a:endParaRPr lang="en-US" sz="1050" dirty="0"/>
+          </a:p>
+        </p:txBody>
+      </p:sp>
+      <p:sp>
+        <p:nvSpPr>
+          <p:cNvPr id="26" name="Text 24"/>
+          <p:cNvSpPr/>
+          <p:nvPr/>
+        </p:nvSpPr>
+        <p:spPr>
+          <a:xfrm>
+            <a:off x="886968" y="4846320"/>
+            <a:ext cx="2907792" cy="502920"/>
+          </a:xfrm>
+          <a:prstGeom prst="rect">
+            <a:avLst/>
+          </a:prstGeom>
+          <a:noFill/>
+          <a:ln/>
+        </p:spPr>
+        <p:txBody>
+          <a:bodyPr wrap="square" lIns="0" tIns="0" rIns="0" bIns="0" rtlCol="0" anchor="t"/>
+          <a:lstStyle/>
+          <a:p>
+            <a:pPr indent="0" marL="0">
+              <a:buNone/>
+            </a:pPr>
+            <a:r>
+              <a:rPr lang="en-US" sz="1050" b="1" dirty="0">
+                <a:solidFill>
+                  <a:srgbClr val="13804F"/>
                 </a:solidFill>
                 <a:latin typeface="Segoe UI Semibold" pitchFamily="34" charset="0"/>
                 <a:ea typeface="Segoe UI Semibold" pitchFamily="34" charset="-122"/>
                 <a:cs typeface="Segoe UI Semibold" pitchFamily="34" charset="-120"/>
               </a:rPr>
-              <a:t>The extension's demo </a:t>
-            </a:r>
-            <a:pPr indent="0" marL="0">
-              <a:spcAft>
-                <a:spcPts val="1300"/>
-              </a:spcAft>
-              <a:buNone/>
-            </a:pPr>
-            <a:r>
-              <a:rPr lang="en-US" sz="1150" dirty="0">
-                <a:solidFill>
-                  <a:srgbClr val="4F5B73"/>
+              <a:t>DUET  </a:t>
+            </a:r>
+            <a:pPr indent="0" marL="0">
+              <a:buNone/>
+            </a:pPr>
+            <a:r>
+              <a:rPr lang="en-US" sz="1050" dirty="0">
+                <a:solidFill>
+                  <a:srgbClr val="0F1C3F"/>
                 </a:solidFill>
                 <a:latin typeface="Segoe UI" pitchFamily="34" charset="0"/>
                 <a:ea typeface="Segoe UI" pitchFamily="34" charset="-122"/>
                 <a:cs typeface="Segoe UI" pitchFamily="34" charset="-120"/>
               </a:rPr>
-              <a:t>runs the app's web build; the home, medicines and car are simulated.</a:t>
-            </a:r>
-            <a:endParaRPr lang="en-US" sz="1150" dirty="0"/>
-          </a:p>
-        </p:txBody>
-      </p:sp>
-      <p:sp>
-        <p:nvSpPr>
-          <p:cNvPr id="13" name="Shape 11"/>
-          <p:cNvSpPr/>
-          <p:nvPr/>
-        </p:nvSpPr>
-        <p:spPr>
-          <a:xfrm>
-            <a:off x="6172200" y="1627632"/>
-            <a:ext cx="5513832" cy="4087368"/>
+              <a:t>The route is set once, to the final place.</a:t>
+            </a:r>
+            <a:endParaRPr lang="en-US" sz="1050" dirty="0"/>
+          </a:p>
+        </p:txBody>
+      </p:sp>
+      <p:sp>
+        <p:nvSpPr>
+          <p:cNvPr id="27" name="Shape 25"/>
+          <p:cNvSpPr/>
+          <p:nvPr/>
+        </p:nvSpPr>
+        <p:spPr>
+          <a:xfrm>
+            <a:off x="4050792" y="3840480"/>
+            <a:ext cx="3218688" cy="1645920"/>
           </a:xfrm>
           <a:prstGeom prst="roundRect">
             <a:avLst>
-              <a:gd name="adj" fmla="val 2237"/>
+              <a:gd name="adj" fmla="val 4444"/>
+            </a:avLst>
+          </a:prstGeom>
+          <a:solidFill>
+            <a:srgbClr val="FFFFFF"/>
+          </a:solidFill>
+          <a:ln w="12700">
+            <a:solidFill>
+              <a:srgbClr val="D9DFEA"/>
+            </a:solidFill>
+            <a:prstDash val="solid"/>
+          </a:ln>
+        </p:spPr>
+      </p:sp>
+      <p:sp>
+        <p:nvSpPr>
+          <p:cNvPr id="28" name="Shape 26"/>
+          <p:cNvSpPr/>
+          <p:nvPr/>
+        </p:nvSpPr>
+        <p:spPr>
+          <a:xfrm>
+            <a:off x="4050792" y="3968496"/>
+            <a:ext cx="54864" cy="1389888"/>
+          </a:xfrm>
+          <a:prstGeom prst="rect">
+            <a:avLst/>
+          </a:prstGeom>
+          <a:solidFill>
+            <a:srgbClr val="13804F"/>
+          </a:solidFill>
+          <a:ln w="12700">
+            <a:solidFill>
+              <a:srgbClr val="13804F"/>
+            </a:solidFill>
+            <a:prstDash val="solid"/>
+          </a:ln>
+        </p:spPr>
+      </p:sp>
+      <p:sp>
+        <p:nvSpPr>
+          <p:cNvPr id="29" name="Text 27"/>
+          <p:cNvSpPr/>
+          <p:nvPr/>
+        </p:nvSpPr>
+        <p:spPr>
+          <a:xfrm>
+            <a:off x="4251960" y="3968496"/>
+            <a:ext cx="2926080" cy="256032"/>
+          </a:xfrm>
+          <a:prstGeom prst="rect">
+            <a:avLst/>
+          </a:prstGeom>
+          <a:noFill/>
+          <a:ln/>
+        </p:spPr>
+        <p:txBody>
+          <a:bodyPr wrap="square" lIns="0" tIns="0" rIns="0" bIns="0" rtlCol="0" anchor="t"/>
+          <a:lstStyle/>
+          <a:p>
+            <a:pPr indent="0" marL="0">
+              <a:buNone/>
+            </a:pPr>
+            <a:r>
+              <a:rPr lang="en-US" sz="1200" dirty="0">
+                <a:solidFill>
+                  <a:srgbClr val="13804F"/>
+                </a:solidFill>
+                <a:latin typeface="Segoe UI Semibold" pitchFamily="34" charset="0"/>
+                <a:ea typeface="Segoe UI Semibold" pitchFamily="34" charset="-122"/>
+                <a:cs typeface="Segoe UI Semibold" pitchFamily="34" charset="-120"/>
+              </a:rPr>
+              <a:t>Galaxy, beside Bixby</a:t>
+            </a:r>
+            <a:endParaRPr lang="en-US" sz="1200" dirty="0"/>
+          </a:p>
+        </p:txBody>
+      </p:sp>
+      <p:sp>
+        <p:nvSpPr>
+          <p:cNvPr id="30" name="Text 28"/>
+          <p:cNvSpPr/>
+          <p:nvPr/>
+        </p:nvSpPr>
+        <p:spPr>
+          <a:xfrm>
+            <a:off x="4251960" y="4297680"/>
+            <a:ext cx="2907792" cy="502920"/>
+          </a:xfrm>
+          <a:prstGeom prst="rect">
+            <a:avLst/>
+          </a:prstGeom>
+          <a:noFill/>
+          <a:ln/>
+        </p:spPr>
+        <p:txBody>
+          <a:bodyPr wrap="square" lIns="0" tIns="0" rIns="0" bIns="0" rtlCol="0" anchor="t"/>
+          <a:lstStyle/>
+          <a:p>
+            <a:pPr indent="0" marL="0">
+              <a:buNone/>
+            </a:pPr>
+            <a:r>
+              <a:rPr lang="en-US" sz="1050" i="1" dirty="0">
+                <a:solidFill>
+                  <a:srgbClr val="0F1C3F"/>
+                </a:solidFill>
+                <a:latin typeface="Segoe UI" pitchFamily="34" charset="0"/>
+                <a:ea typeface="Segoe UI" pitchFamily="34" charset="-122"/>
+                <a:cs typeface="Segoe UI" pitchFamily="34" charset="-120"/>
+              </a:rPr>
+              <a:t>“Send it to Priya… actually, to Mom.”</a:t>
+            </a:r>
+            <a:endParaRPr lang="en-US" sz="1050" dirty="0"/>
+          </a:p>
+        </p:txBody>
+      </p:sp>
+      <p:sp>
+        <p:nvSpPr>
+          <p:cNvPr id="31" name="Text 29"/>
+          <p:cNvSpPr/>
+          <p:nvPr/>
+        </p:nvSpPr>
+        <p:spPr>
+          <a:xfrm>
+            <a:off x="4251960" y="4846320"/>
+            <a:ext cx="2907792" cy="502920"/>
+          </a:xfrm>
+          <a:prstGeom prst="rect">
+            <a:avLst/>
+          </a:prstGeom>
+          <a:noFill/>
+          <a:ln/>
+        </p:spPr>
+        <p:txBody>
+          <a:bodyPr wrap="square" lIns="0" tIns="0" rIns="0" bIns="0" rtlCol="0" anchor="t"/>
+          <a:lstStyle/>
+          <a:p>
+            <a:pPr indent="0" marL="0">
+              <a:buNone/>
+            </a:pPr>
+            <a:r>
+              <a:rPr lang="en-US" sz="1050" b="1" dirty="0">
+                <a:solidFill>
+                  <a:srgbClr val="13804F"/>
+                </a:solidFill>
+                <a:latin typeface="Segoe UI Semibold" pitchFamily="34" charset="0"/>
+                <a:ea typeface="Segoe UI Semibold" pitchFamily="34" charset="-122"/>
+                <a:cs typeface="Segoe UI Semibold" pitchFamily="34" charset="-120"/>
+              </a:rPr>
+              <a:t>DUET  </a:t>
+            </a:r>
+            <a:pPr indent="0" marL="0">
+              <a:buNone/>
+            </a:pPr>
+            <a:r>
+              <a:rPr lang="en-US" sz="1050" dirty="0">
+                <a:solidFill>
+                  <a:srgbClr val="0F1C3F"/>
+                </a:solidFill>
+                <a:latin typeface="Segoe UI" pitchFamily="34" charset="0"/>
+                <a:ea typeface="Segoe UI" pitchFamily="34" charset="-122"/>
+                <a:cs typeface="Segoe UI" pitchFamily="34" charset="-120"/>
+              </a:rPr>
+              <a:t>The message goes once, to Mom.</a:t>
+            </a:r>
+            <a:endParaRPr lang="en-US" sz="1050" dirty="0"/>
+          </a:p>
+        </p:txBody>
+      </p:sp>
+      <p:sp>
+        <p:nvSpPr>
+          <p:cNvPr id="32" name="Shape 30"/>
+          <p:cNvSpPr/>
+          <p:nvPr/>
+        </p:nvSpPr>
+        <p:spPr>
+          <a:xfrm>
+            <a:off x="7680960" y="1600200"/>
+            <a:ext cx="4005072" cy="4114800"/>
+          </a:xfrm>
+          <a:prstGeom prst="roundRect">
+            <a:avLst>
+              <a:gd name="adj" fmla="val 2283"/>
             </a:avLst>
           </a:prstGeom>
           <a:solidFill>
@@ -20353,69 +21073,117 @@
       </p:sp>
       <p:sp>
         <p:nvSpPr>
-          <p:cNvPr id="14" name="Text 12"/>
-          <p:cNvSpPr/>
-          <p:nvPr/>
-        </p:nvSpPr>
-        <p:spPr>
-          <a:xfrm>
-            <a:off x="6355080" y="1755648"/>
-            <a:ext cx="4572000" cy="228600"/>
-          </a:xfrm>
-          <a:prstGeom prst="rect">
-            <a:avLst/>
-          </a:prstGeom>
-          <a:noFill/>
-          <a:ln/>
-        </p:spPr>
-        <p:txBody>
-          <a:bodyPr wrap="square" lIns="0" tIns="0" rIns="0" bIns="0" rtlCol="0" anchor="t"/>
-          <a:lstStyle/>
-          <a:p>
-            <a:pPr indent="0" marL="0">
-              <a:buNone/>
-            </a:pPr>
-            <a:r>
-              <a:rPr lang="en-US" sz="1000" spc="150" kern="0" dirty="0">
-                <a:solidFill>
-                  <a:srgbClr val="13804F"/>
+          <p:cNvPr id="33" name="Text 31"/>
+          <p:cNvSpPr/>
+          <p:nvPr/>
+        </p:nvSpPr>
+        <p:spPr>
+          <a:xfrm>
+            <a:off x="7863840" y="1737360"/>
+            <a:ext cx="3657600" cy="219456"/>
+          </a:xfrm>
+          <a:prstGeom prst="rect">
+            <a:avLst/>
+          </a:prstGeom>
+          <a:noFill/>
+          <a:ln/>
+        </p:spPr>
+        <p:txBody>
+          <a:bodyPr wrap="square" lIns="0" tIns="0" rIns="0" bIns="0" rtlCol="0" anchor="t"/>
+          <a:lstStyle/>
+          <a:p>
+            <a:pPr indent="0" marL="0">
+              <a:buNone/>
+            </a:pPr>
+            <a:r>
+              <a:rPr lang="en-US" sz="950" spc="200" kern="0" dirty="0">
+                <a:solidFill>
+                  <a:srgbClr val="4F5B73"/>
                 </a:solidFill>
                 <a:latin typeface="Segoe UI Semibold" pitchFamily="34" charset="0"/>
                 <a:ea typeface="Segoe UI Semibold" pitchFamily="34" charset="-122"/>
                 <a:cs typeface="Segoe UI Semibold" pitchFamily="34" charset="-120"/>
               </a:rPr>
-              <a:t>NEXT, AS A PRISM WORKLET</a:t>
-            </a:r>
-            <a:endParaRPr lang="en-US" sz="1000" dirty="0"/>
-          </a:p>
-        </p:txBody>
-      </p:sp>
-      <p:sp>
-        <p:nvSpPr>
-          <p:cNvPr id="15" name="Text 13"/>
-          <p:cNvSpPr/>
-          <p:nvPr/>
-        </p:nvSpPr>
-        <p:spPr>
-          <a:xfrm>
-            <a:off x="6355080" y="2084832"/>
-            <a:ext cx="502920" cy="365760"/>
-          </a:xfrm>
-          <a:prstGeom prst="rect">
-            <a:avLst/>
-          </a:prstGeom>
-          <a:noFill/>
-          <a:ln/>
-        </p:spPr>
-        <p:txBody>
-          <a:bodyPr wrap="square" lIns="0" tIns="0" rIns="0" bIns="0" rtlCol="0" anchor="t"/>
-          <a:lstStyle/>
-          <a:p>
-            <a:pPr indent="0" marL="0">
-              <a:buNone/>
-            </a:pPr>
-            <a:r>
-              <a:rPr lang="en-US" sz="1700" dirty="0">
+              <a:t>ROADMAP AS A PRISM WORKLET</a:t>
+            </a:r>
+            <a:endParaRPr lang="en-US" sz="950" dirty="0"/>
+          </a:p>
+        </p:txBody>
+      </p:sp>
+      <p:sp>
+        <p:nvSpPr>
+          <p:cNvPr id="34" name="Shape 32"/>
+          <p:cNvSpPr/>
+          <p:nvPr/>
+        </p:nvSpPr>
+        <p:spPr>
+          <a:xfrm>
+            <a:off x="8074152" y="2240280"/>
+            <a:ext cx="0" cy="2743200"/>
+          </a:xfrm>
+          <a:prstGeom prst="line">
+            <a:avLst/>
+          </a:prstGeom>
+          <a:noFill/>
+          <a:ln w="25400">
+            <a:solidFill>
+              <a:srgbClr val="D9DFEA"/>
+            </a:solidFill>
+            <a:prstDash val="solid"/>
+          </a:ln>
+        </p:spPr>
+      </p:sp>
+      <p:sp>
+        <p:nvSpPr>
+          <p:cNvPr id="35" name="Shape 33"/>
+          <p:cNvSpPr/>
+          <p:nvPr/>
+        </p:nvSpPr>
+        <p:spPr>
+          <a:xfrm>
+            <a:off x="7973568" y="2139696"/>
+            <a:ext cx="201168" cy="201168"/>
+          </a:xfrm>
+          <a:prstGeom prst="ellipse">
+            <a:avLst/>
+          </a:prstGeom>
+          <a:solidFill>
+            <a:srgbClr val="1428A0"/>
+          </a:solidFill>
+          <a:ln w="25400">
+            <a:solidFill>
+              <a:srgbClr val="FFFFFF"/>
+            </a:solidFill>
+            <a:prstDash val="solid"/>
+          </a:ln>
+        </p:spPr>
+      </p:sp>
+      <p:sp>
+        <p:nvSpPr>
+          <p:cNvPr id="36" name="Text 34"/>
+          <p:cNvSpPr/>
+          <p:nvPr/>
+        </p:nvSpPr>
+        <p:spPr>
+          <a:xfrm>
+            <a:off x="8321040" y="2103120"/>
+            <a:ext cx="3246120" cy="274320"/>
+          </a:xfrm>
+          <a:prstGeom prst="rect">
+            <a:avLst/>
+          </a:prstGeom>
+          <a:noFill/>
+          <a:ln/>
+        </p:spPr>
+        <p:txBody>
+          <a:bodyPr wrap="square" lIns="0" tIns="0" rIns="0" bIns="0" rtlCol="0" anchor="t"/>
+          <a:lstStyle/>
+          <a:p>
+            <a:pPr indent="0" marL="0">
+              <a:buNone/>
+            </a:pPr>
+            <a:r>
+              <a:rPr lang="en-US" sz="1150" b="1" spc="150" kern="0" dirty="0">
                 <a:solidFill>
                   <a:srgbClr val="1428A0"/>
                 </a:solidFill>
@@ -20423,38 +21191,13 @@
                 <a:ea typeface="Segoe UI Semibold" pitchFamily="34" charset="-122"/>
                 <a:cs typeface="Segoe UI Semibold" pitchFamily="34" charset="-120"/>
               </a:rPr>
-              <a:t>01</a:t>
-            </a:r>
-            <a:endParaRPr lang="en-US" sz="1700" dirty="0"/>
-          </a:p>
-        </p:txBody>
-      </p:sp>
-      <p:sp>
-        <p:nvSpPr>
-          <p:cNvPr id="16" name="Text 14"/>
-          <p:cNvSpPr/>
-          <p:nvPr/>
-        </p:nvSpPr>
-        <p:spPr>
-          <a:xfrm>
-            <a:off x="6903720" y="2084832"/>
-            <a:ext cx="4617720" cy="685800"/>
-          </a:xfrm>
-          <a:prstGeom prst="rect">
-            <a:avLst/>
-          </a:prstGeom>
-          <a:noFill/>
-          <a:ln/>
-        </p:spPr>
-        <p:txBody>
-          <a:bodyPr wrap="square" lIns="0" tIns="0" rIns="0" bIns="0" rtlCol="0" anchor="t"/>
-          <a:lstStyle/>
-          <a:p>
-            <a:pPr indent="0" marL="0">
-              <a:buNone/>
-            </a:pPr>
-            <a:r>
-              <a:rPr lang="en-US" sz="1030" b="1" dirty="0">
+              <a:t>NOW  </a:t>
+            </a:r>
+            <a:pPr indent="0" marL="0">
+              <a:buNone/>
+            </a:pPr>
+            <a:r>
+              <a:rPr lang="en-US" sz="1150" b="1" dirty="0">
                 <a:solidFill>
                   <a:srgbClr val="0F1C3F"/>
                 </a:solidFill>
@@ -20462,16 +21205,38 @@
                 <a:ea typeface="Segoe UI Semibold" pitchFamily="34" charset="-122"/>
                 <a:cs typeface="Segoe UI Semibold" pitchFamily="34" charset="-120"/>
               </a:rPr>
-              <a:t>On-device Gemma on Galaxy</a:t>
-            </a:r>
-            <a:endParaRPr lang="en-US" sz="1030" dirty="0"/>
-          </a:p>
-          <a:p>
-            <a:pPr indent="0" marL="0">
-              <a:buNone/>
-            </a:pPr>
-            <a:r>
-              <a:rPr lang="en-US" sz="1030" dirty="0">
+              <a:t>Round 1</a:t>
+            </a:r>
+            <a:endParaRPr lang="en-US" sz="1150" dirty="0"/>
+          </a:p>
+        </p:txBody>
+      </p:sp>
+      <p:sp>
+        <p:nvSpPr>
+          <p:cNvPr id="37" name="Text 35"/>
+          <p:cNvSpPr/>
+          <p:nvPr/>
+        </p:nvSpPr>
+        <p:spPr>
+          <a:xfrm>
+            <a:off x="8321040" y="2395728"/>
+            <a:ext cx="3246120" cy="822960"/>
+          </a:xfrm>
+          <a:prstGeom prst="rect">
+            <a:avLst/>
+          </a:prstGeom>
+          <a:noFill/>
+          <a:ln/>
+        </p:spPr>
+        <p:txBody>
+          <a:bodyPr wrap="square" lIns="0" tIns="0" rIns="0" bIns="0" rtlCol="0" anchor="t"/>
+          <a:lstStyle/>
+          <a:p>
+            <a:pPr indent="0" marL="0">
+              <a:buNone/>
+            </a:pPr>
+            <a:r>
+              <a:rPr lang="en-US" sz="1000" dirty="0">
                 <a:solidFill>
                   <a:srgbClr val="4F5B73"/>
                 </a:solidFill>
@@ -20479,77 +21244,77 @@
                 <a:ea typeface="Segoe UI" pitchFamily="34" charset="-122"/>
                 <a:cs typeface="Segoe UI" pitchFamily="34" charset="-120"/>
               </a:rPr>
-              <a:t>No round trip and no key limits: the answer's latency drops, and the user's words never leave the phone.</a:t>
-            </a:r>
-            <a:endParaRPr lang="en-US" sz="1030" dirty="0"/>
-          </a:p>
-        </p:txBody>
-      </p:sp>
-      <p:sp>
-        <p:nvSpPr>
-          <p:cNvPr id="17" name="Text 15"/>
-          <p:cNvSpPr/>
-          <p:nvPr/>
-        </p:nvSpPr>
-        <p:spPr>
-          <a:xfrm>
-            <a:off x="6355080" y="2798064"/>
-            <a:ext cx="502920" cy="365760"/>
-          </a:xfrm>
-          <a:prstGeom prst="rect">
-            <a:avLst/>
-          </a:prstGeom>
-          <a:noFill/>
-          <a:ln/>
-        </p:spPr>
-        <p:txBody>
-          <a:bodyPr wrap="square" lIns="0" tIns="0" rIns="0" bIns="0" rtlCol="0" anchor="t"/>
-          <a:lstStyle/>
-          <a:p>
-            <a:pPr indent="0" marL="0">
-              <a:buNone/>
-            </a:pPr>
-            <a:r>
-              <a:rPr lang="en-US" sz="1700" dirty="0">
-                <a:solidFill>
-                  <a:srgbClr val="1428A0"/>
+              <a:t>DUET scores 0.81 Pass@1 on Full-Duplex-Bench v3, and runs on a Samsung phone in three modes.</a:t>
+            </a:r>
+            <a:endParaRPr lang="en-US" sz="1000" dirty="0"/>
+          </a:p>
+        </p:txBody>
+      </p:sp>
+      <p:sp>
+        <p:nvSpPr>
+          <p:cNvPr id="38" name="Shape 36"/>
+          <p:cNvSpPr/>
+          <p:nvPr/>
+        </p:nvSpPr>
+        <p:spPr>
+          <a:xfrm>
+            <a:off x="7973568" y="3328416"/>
+            <a:ext cx="201168" cy="201168"/>
+          </a:xfrm>
+          <a:prstGeom prst="ellipse">
+            <a:avLst/>
+          </a:prstGeom>
+          <a:solidFill>
+            <a:srgbClr val="5B3FC4"/>
+          </a:solidFill>
+          <a:ln w="25400">
+            <a:solidFill>
+              <a:srgbClr val="FFFFFF"/>
+            </a:solidFill>
+            <a:prstDash val="solid"/>
+          </a:ln>
+        </p:spPr>
+      </p:sp>
+      <p:sp>
+        <p:nvSpPr>
+          <p:cNvPr id="39" name="Text 37"/>
+          <p:cNvSpPr/>
+          <p:nvPr/>
+        </p:nvSpPr>
+        <p:spPr>
+          <a:xfrm>
+            <a:off x="8321040" y="3291840"/>
+            <a:ext cx="3246120" cy="274320"/>
+          </a:xfrm>
+          <a:prstGeom prst="rect">
+            <a:avLst/>
+          </a:prstGeom>
+          <a:noFill/>
+          <a:ln/>
+        </p:spPr>
+        <p:txBody>
+          <a:bodyPr wrap="square" lIns="0" tIns="0" rIns="0" bIns="0" rtlCol="0" anchor="t"/>
+          <a:lstStyle/>
+          <a:p>
+            <a:pPr indent="0" marL="0">
+              <a:buNone/>
+            </a:pPr>
+            <a:r>
+              <a:rPr lang="en-US" sz="1150" b="1" spc="150" kern="0" dirty="0">
+                <a:solidFill>
+                  <a:srgbClr val="5B3FC4"/>
                 </a:solidFill>
                 <a:latin typeface="Segoe UI Semibold" pitchFamily="34" charset="0"/>
                 <a:ea typeface="Segoe UI Semibold" pitchFamily="34" charset="-122"/>
                 <a:cs typeface="Segoe UI Semibold" pitchFamily="34" charset="-120"/>
               </a:rPr>
-              <a:t>02</a:t>
-            </a:r>
-            <a:endParaRPr lang="en-US" sz="1700" dirty="0"/>
-          </a:p>
-        </p:txBody>
-      </p:sp>
-      <p:sp>
-        <p:nvSpPr>
-          <p:cNvPr id="18" name="Text 16"/>
-          <p:cNvSpPr/>
-          <p:nvPr/>
-        </p:nvSpPr>
-        <p:spPr>
-          <a:xfrm>
-            <a:off x="6903720" y="2798064"/>
-            <a:ext cx="4617720" cy="685800"/>
-          </a:xfrm>
-          <a:prstGeom prst="rect">
-            <a:avLst/>
-          </a:prstGeom>
-          <a:noFill/>
-          <a:ln/>
-        </p:spPr>
-        <p:txBody>
-          <a:bodyPr wrap="square" lIns="0" tIns="0" rIns="0" bIns="0" rtlCol="0" anchor="t"/>
-          <a:lstStyle/>
-          <a:p>
-            <a:pPr indent="0" marL="0">
-              <a:buNone/>
-            </a:pPr>
-            <a:r>
-              <a:rPr lang="en-US" sz="1030" b="1" dirty="0">
+              <a:t>NEXT  </a:t>
+            </a:r>
+            <a:pPr indent="0" marL="0">
+              <a:buNone/>
+            </a:pPr>
+            <a:r>
+              <a:rPr lang="en-US" sz="1150" b="1" dirty="0">
                 <a:solidFill>
                   <a:srgbClr val="0F1C3F"/>
                 </a:solidFill>
@@ -20557,16 +21322,38 @@
                 <a:ea typeface="Segoe UI Semibold" pitchFamily="34" charset="-122"/>
                 <a:cs typeface="Segoe UI Semibold" pitchFamily="34" charset="-120"/>
               </a:rPr>
-              <a:t>Confirm before acting on codes</a:t>
-            </a:r>
-            <a:endParaRPr lang="en-US" sz="1030" dirty="0"/>
-          </a:p>
-          <a:p>
-            <a:pPr indent="0" marL="0">
-              <a:buNone/>
-            </a:pPr>
-            <a:r>
-              <a:rPr lang="en-US" sz="1030" dirty="0">
+              <a:t>On the device</a:t>
+            </a:r>
+            <a:endParaRPr lang="en-US" sz="1150" dirty="0"/>
+          </a:p>
+        </p:txBody>
+      </p:sp>
+      <p:sp>
+        <p:nvSpPr>
+          <p:cNvPr id="40" name="Text 38"/>
+          <p:cNvSpPr/>
+          <p:nvPr/>
+        </p:nvSpPr>
+        <p:spPr>
+          <a:xfrm>
+            <a:off x="8321040" y="3584448"/>
+            <a:ext cx="3246120" cy="822960"/>
+          </a:xfrm>
+          <a:prstGeom prst="rect">
+            <a:avLst/>
+          </a:prstGeom>
+          <a:noFill/>
+          <a:ln/>
+        </p:spPr>
+        <p:txBody>
+          <a:bodyPr wrap="square" lIns="0" tIns="0" rIns="0" bIns="0" rtlCol="0" anchor="t"/>
+          <a:lstStyle/>
+          <a:p>
+            <a:pPr indent="0" marL="0">
+              <a:buNone/>
+            </a:pPr>
+            <a:r>
+              <a:rPr lang="en-US" sz="1000" dirty="0">
                 <a:solidFill>
                   <a:srgbClr val="4F5B73"/>
                 </a:solidFill>
@@ -20574,77 +21361,77 @@
                 <a:ea typeface="Segoe UI" pitchFamily="34" charset="-122"/>
                 <a:cs typeface="Segoe UI" pitchFamily="34" charset="-120"/>
               </a:rPr>
-              <a:t>Recognizer confidence per word; a low-confidence order id is read back before the tool runs.</a:t>
-            </a:r>
-            <a:endParaRPr lang="en-US" sz="1030" dirty="0"/>
-          </a:p>
-        </p:txBody>
-      </p:sp>
-      <p:sp>
-        <p:nvSpPr>
-          <p:cNvPr id="19" name="Text 17"/>
-          <p:cNvSpPr/>
-          <p:nvPr/>
-        </p:nvSpPr>
-        <p:spPr>
-          <a:xfrm>
-            <a:off x="6355080" y="3511296"/>
-            <a:ext cx="502920" cy="365760"/>
-          </a:xfrm>
-          <a:prstGeom prst="rect">
-            <a:avLst/>
-          </a:prstGeom>
-          <a:noFill/>
-          <a:ln/>
-        </p:spPr>
-        <p:txBody>
-          <a:bodyPr wrap="square" lIns="0" tIns="0" rIns="0" bIns="0" rtlCol="0" anchor="t"/>
-          <a:lstStyle/>
-          <a:p>
-            <a:pPr indent="0" marL="0">
-              <a:buNone/>
-            </a:pPr>
-            <a:r>
-              <a:rPr lang="en-US" sz="1700" dirty="0">
-                <a:solidFill>
-                  <a:srgbClr val="1428A0"/>
+              <a:t>Gemma on Galaxy: no round trip, no key limits, and the user's words stay on the phone. A code the recognizer is unsure of is read back before any tool runs.</a:t>
+            </a:r>
+            <a:endParaRPr lang="en-US" sz="1000" dirty="0"/>
+          </a:p>
+        </p:txBody>
+      </p:sp>
+      <p:sp>
+        <p:nvSpPr>
+          <p:cNvPr id="41" name="Shape 39"/>
+          <p:cNvSpPr/>
+          <p:nvPr/>
+        </p:nvSpPr>
+        <p:spPr>
+          <a:xfrm>
+            <a:off x="7973568" y="4517136"/>
+            <a:ext cx="201168" cy="201168"/>
+          </a:xfrm>
+          <a:prstGeom prst="ellipse">
+            <a:avLst/>
+          </a:prstGeom>
+          <a:solidFill>
+            <a:srgbClr val="13804F"/>
+          </a:solidFill>
+          <a:ln w="25400">
+            <a:solidFill>
+              <a:srgbClr val="FFFFFF"/>
+            </a:solidFill>
+            <a:prstDash val="solid"/>
+          </a:ln>
+        </p:spPr>
+      </p:sp>
+      <p:sp>
+        <p:nvSpPr>
+          <p:cNvPr id="42" name="Text 40"/>
+          <p:cNvSpPr/>
+          <p:nvPr/>
+        </p:nvSpPr>
+        <p:spPr>
+          <a:xfrm>
+            <a:off x="8321040" y="4480560"/>
+            <a:ext cx="3246120" cy="274320"/>
+          </a:xfrm>
+          <a:prstGeom prst="rect">
+            <a:avLst/>
+          </a:prstGeom>
+          <a:noFill/>
+          <a:ln/>
+        </p:spPr>
+        <p:txBody>
+          <a:bodyPr wrap="square" lIns="0" tIns="0" rIns="0" bIns="0" rtlCol="0" anchor="t"/>
+          <a:lstStyle/>
+          <a:p>
+            <a:pPr indent="0" marL="0">
+              <a:buNone/>
+            </a:pPr>
+            <a:r>
+              <a:rPr lang="en-US" sz="1150" b="1" spc="150" kern="0" dirty="0">
+                <a:solidFill>
+                  <a:srgbClr val="13804F"/>
                 </a:solidFill>
                 <a:latin typeface="Segoe UI Semibold" pitchFamily="34" charset="0"/>
                 <a:ea typeface="Segoe UI Semibold" pitchFamily="34" charset="-122"/>
                 <a:cs typeface="Segoe UI Semibold" pitchFamily="34" charset="-120"/>
               </a:rPr>
-              <a:t>03</a:t>
-            </a:r>
-            <a:endParaRPr lang="en-US" sz="1700" dirty="0"/>
-          </a:p>
-        </p:txBody>
-      </p:sp>
-      <p:sp>
-        <p:nvSpPr>
-          <p:cNvPr id="20" name="Text 18"/>
-          <p:cNvSpPr/>
-          <p:nvPr/>
-        </p:nvSpPr>
-        <p:spPr>
-          <a:xfrm>
-            <a:off x="6903720" y="3511296"/>
-            <a:ext cx="4617720" cy="685800"/>
-          </a:xfrm>
-          <a:prstGeom prst="rect">
-            <a:avLst/>
-          </a:prstGeom>
-          <a:noFill/>
-          <a:ln/>
-        </p:spPr>
-        <p:txBody>
-          <a:bodyPr wrap="square" lIns="0" tIns="0" rIns="0" bIns="0" rtlCol="0" anchor="t"/>
-          <a:lstStyle/>
-          <a:p>
-            <a:pPr indent="0" marL="0">
-              <a:buNone/>
-            </a:pPr>
-            <a:r>
-              <a:rPr lang="en-US" sz="1030" b="1" dirty="0">
+              <a:t>THEN  </a:t>
+            </a:r>
+            <a:pPr indent="0" marL="0">
+              <a:buNone/>
+            </a:pPr>
+            <a:r>
+              <a:rPr lang="en-US" sz="1150" b="1" dirty="0">
                 <a:solidFill>
                   <a:srgbClr val="0F1C3F"/>
                 </a:solidFill>
@@ -20652,16 +21439,38 @@
                 <a:ea typeface="Segoe UI Semibold" pitchFamily="34" charset="-122"/>
                 <a:cs typeface="Segoe UI Semibold" pitchFamily="34" charset="-120"/>
               </a:rPr>
-              <a:t>Speculative reads, gated writes</a:t>
-            </a:r>
-            <a:endParaRPr lang="en-US" sz="1030" dirty="0"/>
-          </a:p>
-          <a:p>
-            <a:pPr indent="0" marL="0">
-              <a:buNone/>
-            </a:pPr>
-            <a:r>
-              <a:rPr lang="en-US" sz="1030" dirty="0">
+              <a:t>Across Samsung</a:t>
+            </a:r>
+            <a:endParaRPr lang="en-US" sz="1150" dirty="0"/>
+          </a:p>
+        </p:txBody>
+      </p:sp>
+      <p:sp>
+        <p:nvSpPr>
+          <p:cNvPr id="43" name="Text 41"/>
+          <p:cNvSpPr/>
+          <p:nvPr/>
+        </p:nvSpPr>
+        <p:spPr>
+          <a:xfrm>
+            <a:off x="8321040" y="4773168"/>
+            <a:ext cx="3246120" cy="822960"/>
+          </a:xfrm>
+          <a:prstGeom prst="rect">
+            <a:avLst/>
+          </a:prstGeom>
+          <a:noFill/>
+          <a:ln/>
+        </p:spPr>
+        <p:txBody>
+          <a:bodyPr wrap="square" lIns="0" tIns="0" rIns="0" bIns="0" rtlCol="0" anchor="t"/>
+          <a:lstStyle/>
+          <a:p>
+            <a:pPr indent="0" marL="0">
+              <a:buNone/>
+            </a:pPr>
+            <a:r>
+              <a:rPr lang="en-US" sz="1000" dirty="0">
                 <a:solidFill>
                   <a:srgbClr val="4F5B73"/>
                 </a:solidFill>
@@ -20669,211 +21478,21 @@
                 <a:ea typeface="Segoe UI" pitchFamily="34" charset="-122"/>
                 <a:cs typeface="Segoe UI" pitchFamily="34" charset="-120"/>
               </a:rPr>
-              <a:t>Start safe lookups while the user is still talking; keep every state change behind the gate.</a:t>
-            </a:r>
-            <a:endParaRPr lang="en-US" sz="1030" dirty="0"/>
-          </a:p>
-        </p:txBody>
-      </p:sp>
-      <p:sp>
-        <p:nvSpPr>
-          <p:cNvPr id="21" name="Text 19"/>
-          <p:cNvSpPr/>
-          <p:nvPr/>
-        </p:nvSpPr>
-        <p:spPr>
-          <a:xfrm>
-            <a:off x="6355080" y="4224528"/>
-            <a:ext cx="502920" cy="365760"/>
-          </a:xfrm>
-          <a:prstGeom prst="rect">
-            <a:avLst/>
-          </a:prstGeom>
-          <a:noFill/>
-          <a:ln/>
-        </p:spPr>
-        <p:txBody>
-          <a:bodyPr wrap="square" lIns="0" tIns="0" rIns="0" bIns="0" rtlCol="0" anchor="t"/>
-          <a:lstStyle/>
-          <a:p>
-            <a:pPr indent="0" marL="0">
-              <a:buNone/>
-            </a:pPr>
-            <a:r>
-              <a:rPr lang="en-US" sz="1700" dirty="0">
-                <a:solidFill>
-                  <a:srgbClr val="1428A0"/>
-                </a:solidFill>
-                <a:latin typeface="Segoe UI Semibold" pitchFamily="34" charset="0"/>
-                <a:ea typeface="Segoe UI Semibold" pitchFamily="34" charset="-122"/>
-                <a:cs typeface="Segoe UI Semibold" pitchFamily="34" charset="-120"/>
-              </a:rPr>
-              <a:t>04</a:t>
-            </a:r>
-            <a:endParaRPr lang="en-US" sz="1700" dirty="0"/>
-          </a:p>
-        </p:txBody>
-      </p:sp>
-      <p:sp>
-        <p:nvSpPr>
-          <p:cNvPr id="22" name="Text 20"/>
-          <p:cNvSpPr/>
-          <p:nvPr/>
-        </p:nvSpPr>
-        <p:spPr>
-          <a:xfrm>
-            <a:off x="6903720" y="4224528"/>
-            <a:ext cx="4617720" cy="685800"/>
-          </a:xfrm>
-          <a:prstGeom prst="rect">
-            <a:avLst/>
-          </a:prstGeom>
-          <a:noFill/>
-          <a:ln/>
-        </p:spPr>
-        <p:txBody>
-          <a:bodyPr wrap="square" lIns="0" tIns="0" rIns="0" bIns="0" rtlCol="0" anchor="t"/>
-          <a:lstStyle/>
-          <a:p>
-            <a:pPr indent="0" marL="0">
-              <a:buNone/>
-            </a:pPr>
-            <a:r>
-              <a:rPr lang="en-US" sz="1030" b="1" dirty="0">
-                <a:solidFill>
-                  <a:srgbClr val="0F1C3F"/>
-                </a:solidFill>
-                <a:latin typeface="Segoe UI Semibold" pitchFamily="34" charset="0"/>
-                <a:ea typeface="Segoe UI Semibold" pitchFamily="34" charset="-122"/>
-                <a:cs typeface="Segoe UI Semibold" pitchFamily="34" charset="-120"/>
-              </a:rPr>
-              <a:t>SmartThings and Android Auto</a:t>
-            </a:r>
-            <a:endParaRPr lang="en-US" sz="1030" dirty="0"/>
-          </a:p>
-          <a:p>
-            <a:pPr indent="0" marL="0">
-              <a:buNone/>
-            </a:pPr>
-            <a:r>
-              <a:rPr lang="en-US" sz="1030" dirty="0">
-                <a:solidFill>
-                  <a:srgbClr val="4F5B73"/>
-                </a:solidFill>
-                <a:latin typeface="Segoe UI" pitchFamily="34" charset="0"/>
-                <a:ea typeface="Segoe UI" pitchFamily="34" charset="-122"/>
-                <a:cs typeface="Segoe UI" pitchFamily="34" charset="-120"/>
-              </a:rPr>
-              <a:t>The Care and Drive modes on real devices, with Knox-consented health reads.</a:t>
-            </a:r>
-            <a:endParaRPr lang="en-US" sz="1030" dirty="0"/>
-          </a:p>
-        </p:txBody>
-      </p:sp>
-      <p:sp>
-        <p:nvSpPr>
-          <p:cNvPr id="23" name="Text 21"/>
-          <p:cNvSpPr/>
-          <p:nvPr/>
-        </p:nvSpPr>
-        <p:spPr>
-          <a:xfrm>
-            <a:off x="6355080" y="4937760"/>
-            <a:ext cx="502920" cy="365760"/>
-          </a:xfrm>
-          <a:prstGeom prst="rect">
-            <a:avLst/>
-          </a:prstGeom>
-          <a:noFill/>
-          <a:ln/>
-        </p:spPr>
-        <p:txBody>
-          <a:bodyPr wrap="square" lIns="0" tIns="0" rIns="0" bIns="0" rtlCol="0" anchor="t"/>
-          <a:lstStyle/>
-          <a:p>
-            <a:pPr indent="0" marL="0">
-              <a:buNone/>
-            </a:pPr>
-            <a:r>
-              <a:rPr lang="en-US" sz="1700" dirty="0">
-                <a:solidFill>
-                  <a:srgbClr val="1428A0"/>
-                </a:solidFill>
-                <a:latin typeface="Segoe UI Semibold" pitchFamily="34" charset="0"/>
-                <a:ea typeface="Segoe UI Semibold" pitchFamily="34" charset="-122"/>
-                <a:cs typeface="Segoe UI Semibold" pitchFamily="34" charset="-120"/>
-              </a:rPr>
-              <a:t>05</a:t>
-            </a:r>
-            <a:endParaRPr lang="en-US" sz="1700" dirty="0"/>
-          </a:p>
-        </p:txBody>
-      </p:sp>
-      <p:sp>
-        <p:nvSpPr>
-          <p:cNvPr id="24" name="Text 22"/>
-          <p:cNvSpPr/>
-          <p:nvPr/>
-        </p:nvSpPr>
-        <p:spPr>
-          <a:xfrm>
-            <a:off x="6903720" y="4937760"/>
-            <a:ext cx="4617720" cy="685800"/>
-          </a:xfrm>
-          <a:prstGeom prst="rect">
-            <a:avLst/>
-          </a:prstGeom>
-          <a:noFill/>
-          <a:ln/>
-        </p:spPr>
-        <p:txBody>
-          <a:bodyPr wrap="square" lIns="0" tIns="0" rIns="0" bIns="0" rtlCol="0" anchor="t"/>
-          <a:lstStyle/>
-          <a:p>
-            <a:pPr indent="0" marL="0">
-              <a:buNone/>
-            </a:pPr>
-            <a:r>
-              <a:rPr lang="en-US" sz="1030" b="1" dirty="0">
-                <a:solidFill>
-                  <a:srgbClr val="0F1C3F"/>
-                </a:solidFill>
-                <a:latin typeface="Segoe UI Semibold" pitchFamily="34" charset="0"/>
-                <a:ea typeface="Segoe UI Semibold" pitchFamily="34" charset="-122"/>
-                <a:cs typeface="Segoe UI Semibold" pitchFamily="34" charset="-120"/>
-              </a:rPr>
-              <a:t>Field metrics</a:t>
-            </a:r>
-            <a:endParaRPr lang="en-US" sz="1030" dirty="0"/>
-          </a:p>
-          <a:p>
-            <a:pPr indent="0" marL="0">
-              <a:buNone/>
-            </a:pPr>
-            <a:r>
-              <a:rPr lang="en-US" sz="1030" dirty="0">
-                <a:solidFill>
-                  <a:srgbClr val="4F5B73"/>
-                </a:solidFill>
-                <a:latin typeface="Segoe UI" pitchFamily="34" charset="0"/>
-                <a:ea typeface="Segoe UI" pitchFamily="34" charset="-122"/>
-                <a:cs typeface="Segoe UI" pitchFamily="34" charset="-120"/>
-              </a:rPr>
-              <a:t>Stale-action rate, duplicate-action rate and time to first feedback, measured on real users.</a:t>
-            </a:r>
-            <a:endParaRPr lang="en-US" sz="1030" dirty="0"/>
-          </a:p>
-        </p:txBody>
-      </p:sp>
-      <p:sp>
-        <p:nvSpPr>
-          <p:cNvPr id="25" name="Shape 23"/>
-          <p:cNvSpPr/>
-          <p:nvPr/>
-        </p:nvSpPr>
-        <p:spPr>
-          <a:xfrm>
-            <a:off x="502920" y="5870448"/>
+              <a:t>SmartThings, Android Auto and the service line on real devices, measured by stale-action and duplicate-action rates.</a:t>
+            </a:r>
+            <a:endParaRPr lang="en-US" sz="1000" dirty="0"/>
+          </a:p>
+        </p:txBody>
+      </p:sp>
+      <p:sp>
+        <p:nvSpPr>
+          <p:cNvPr id="44" name="Shape 42"/>
+          <p:cNvSpPr/>
+          <p:nvPr/>
+        </p:nvSpPr>
+        <p:spPr>
+          <a:xfrm>
+            <a:off x="502920" y="5888736"/>
             <a:ext cx="3566160" cy="347472"/>
           </a:xfrm>
           <a:prstGeom prst="roundRect">
@@ -20894,13 +21513,13 @@
       </p:sp>
       <p:sp>
         <p:nvSpPr>
-          <p:cNvPr id="26" name="Text 24"/>
-          <p:cNvSpPr/>
-          <p:nvPr/>
-        </p:nvSpPr>
-        <p:spPr>
-          <a:xfrm>
-            <a:off x="502920" y="5870448"/>
+          <p:cNvPr id="45" name="Text 43"/>
+          <p:cNvSpPr/>
+          <p:nvPr/>
+        </p:nvSpPr>
+        <p:spPr>
+          <a:xfrm>
+            <a:off x="502920" y="5888736"/>
             <a:ext cx="3566160" cy="347472"/>
           </a:xfrm>
           <a:prstGeom prst="rect">
@@ -20933,13 +21552,13 @@
       </p:sp>
       <p:sp>
         <p:nvSpPr>
-          <p:cNvPr id="27" name="Text 25"/>
-          <p:cNvSpPr/>
-          <p:nvPr/>
-        </p:nvSpPr>
-        <p:spPr>
-          <a:xfrm>
-            <a:off x="4297680" y="5870448"/>
+          <p:cNvPr id="46" name="Text 44"/>
+          <p:cNvSpPr/>
+          <p:nvPr/>
+        </p:nvSpPr>
+        <p:spPr>
+          <a:xfrm>
+            <a:off x="4297680" y="5888736"/>
             <a:ext cx="7406640" cy="347472"/>
           </a:xfrm>
           <a:prstGeom prst="rect">

</xml_diff>